<commit_message>
Aulia : menambahkan file kertas kerja 3rd party
</commit_message>
<xml_diff>
--- a/Improvement/HEAD-OFFICE/QCP LaSak/QCP_LaSak_SurveyDiv HO.pptx
+++ b/Improvement/HEAD-OFFICE/QCP LaSak/QCP_LaSak_SurveyDiv HO.pptx
@@ -115,10 +115,10 @@
   </p:defaultTextStyle>
   <p:extLst>
     <p:ext uri="{EFAFB233-063F-42B5-8137-9DF3F51BA10A}">
-      <p15:sldGuideLst xmlns:p15="http://schemas.microsoft.com/office/powerpoint/2012/main"/>
+      <p15:sldGuideLst xmlns:p15="http://schemas.microsoft.com/office/powerpoint/2012/main" xmlns=""/>
     </p:ext>
     <p:ext uri="{2D200454-40CA-4A62-9FC3-DE9A4176ACB9}">
-      <p15:notesGuideLst xmlns:p15="http://schemas.microsoft.com/office/powerpoint/2012/main"/>
+      <p15:notesGuideLst xmlns:p15="http://schemas.microsoft.com/office/powerpoint/2012/main" xmlns=""/>
     </p:ext>
   </p:extLst>
 </p:presentation>
@@ -151,7 +151,7 @@
           <p:cNvPr id="2" name="Header Placeholder 1">
             <a:extLst>
               <a:ext uri="{FF2B5EF4-FFF2-40B4-BE49-F238E27FC236}">
-                <a16:creationId xmlns:a16="http://schemas.microsoft.com/office/drawing/2014/main" id="{D9A1C542-D91E-9005-AC44-3CEF088E7321}"/>
+                <a16:creationId xmlns:a16="http://schemas.microsoft.com/office/drawing/2014/main" xmlns="" id="{D9A1C542-D91E-9005-AC44-3CEF088E7321}"/>
               </a:ext>
             </a:extLst>
           </p:cNvPr>
@@ -188,7 +188,7 @@
           <p:cNvPr id="3" name="Date Placeholder 2">
             <a:extLst>
               <a:ext uri="{FF2B5EF4-FFF2-40B4-BE49-F238E27FC236}">
-                <a16:creationId xmlns:a16="http://schemas.microsoft.com/office/drawing/2014/main" id="{45494211-0049-0F88-23E8-3033F5787EE1}"/>
+                <a16:creationId xmlns:a16="http://schemas.microsoft.com/office/drawing/2014/main" xmlns="" id="{45494211-0049-0F88-23E8-3033F5787EE1}"/>
               </a:ext>
             </a:extLst>
           </p:cNvPr>
@@ -218,7 +218,7 @@
           <a:p>
             <a:fld id="{1A61F35B-5A85-4588-9AA9-A3035B93CC37}" type="datetimeFigureOut">
               <a:rPr lang="en-ID" smtClean="0"/>
-              <a:t>08/04/2026</a:t>
+              <a:t>16/04/2026</a:t>
             </a:fld>
             <a:endParaRPr lang="en-ID"/>
           </a:p>
@@ -229,7 +229,7 @@
           <p:cNvPr id="4" name="Footer Placeholder 3">
             <a:extLst>
               <a:ext uri="{FF2B5EF4-FFF2-40B4-BE49-F238E27FC236}">
-                <a16:creationId xmlns:a16="http://schemas.microsoft.com/office/drawing/2014/main" id="{F754DD8D-FAB4-6488-A413-AC45931FBC91}"/>
+                <a16:creationId xmlns:a16="http://schemas.microsoft.com/office/drawing/2014/main" xmlns="" id="{F754DD8D-FAB4-6488-A413-AC45931FBC91}"/>
               </a:ext>
             </a:extLst>
           </p:cNvPr>
@@ -266,7 +266,7 @@
           <p:cNvPr id="5" name="Slide Number Placeholder 4">
             <a:extLst>
               <a:ext uri="{FF2B5EF4-FFF2-40B4-BE49-F238E27FC236}">
-                <a16:creationId xmlns:a16="http://schemas.microsoft.com/office/drawing/2014/main" id="{675CE700-3614-28AF-AEB7-F0412751DF0B}"/>
+                <a16:creationId xmlns:a16="http://schemas.microsoft.com/office/drawing/2014/main" xmlns="" id="{675CE700-3614-28AF-AEB7-F0412751DF0B}"/>
               </a:ext>
             </a:extLst>
           </p:cNvPr>
@@ -349,7 +349,7 @@
           <p:cNvPr id="2" name="Title 1">
             <a:extLst>
               <a:ext uri="{FF2B5EF4-FFF2-40B4-BE49-F238E27FC236}">
-                <a16:creationId xmlns:a16="http://schemas.microsoft.com/office/drawing/2014/main" id="{51A296A7-5D42-09BE-1062-2BDA98ED6018}"/>
+                <a16:creationId xmlns:a16="http://schemas.microsoft.com/office/drawing/2014/main" xmlns="" id="{51A296A7-5D42-09BE-1062-2BDA98ED6018}"/>
               </a:ext>
             </a:extLst>
           </p:cNvPr>
@@ -404,6 +404,13 @@
                 <a:cs typeface="Calibri" panose="020F0502020204030204" pitchFamily="34" charset="0"/>
               </a:rPr>
               <a:t>Judul</a:t>
+            </a:r>
+            <a:r>
+              <a:rPr lang="en-US" sz="4400" b="1" spc="-150" dirty="0">
+                <a:latin typeface="Montserrat" pitchFamily="2" charset="0"/>
+                <a:cs typeface="Calibri" panose="020F0502020204030204" pitchFamily="34" charset="0"/>
+              </a:rPr>
+              <a:t/>
             </a:r>
             <a:br>
               <a:rPr lang="en-US" sz="4400" b="1" spc="-150" dirty="0">
@@ -471,7 +478,7 @@
           <p:cNvPr id="2" name="Title 1">
             <a:extLst>
               <a:ext uri="{FF2B5EF4-FFF2-40B4-BE49-F238E27FC236}">
-                <a16:creationId xmlns:a16="http://schemas.microsoft.com/office/drawing/2014/main" id="{B0002496-EBCC-37DD-1311-B96EAF3E42AF}"/>
+                <a16:creationId xmlns:a16="http://schemas.microsoft.com/office/drawing/2014/main" xmlns="" id="{B0002496-EBCC-37DD-1311-B96EAF3E42AF}"/>
               </a:ext>
             </a:extLst>
           </p:cNvPr>
@@ -536,7 +543,7 @@
           <p:cNvPr id="3" name="Content Placeholder 2">
             <a:extLst>
               <a:ext uri="{FF2B5EF4-FFF2-40B4-BE49-F238E27FC236}">
-                <a16:creationId xmlns:a16="http://schemas.microsoft.com/office/drawing/2014/main" id="{48D339C4-CB77-A558-C32F-0B82F368905F}"/>
+                <a16:creationId xmlns:a16="http://schemas.microsoft.com/office/drawing/2014/main" xmlns="" id="{48D339C4-CB77-A558-C32F-0B82F368905F}"/>
               </a:ext>
             </a:extLst>
           </p:cNvPr>
@@ -996,7 +1003,7 @@
           <p:cNvPr id="2" name="TextBox 1">
             <a:extLst>
               <a:ext uri="{FF2B5EF4-FFF2-40B4-BE49-F238E27FC236}">
-                <a16:creationId xmlns:a16="http://schemas.microsoft.com/office/drawing/2014/main" id="{C5E121B9-3BB2-808C-1856-CC06B583F8EE}"/>
+                <a16:creationId xmlns:a16="http://schemas.microsoft.com/office/drawing/2014/main" xmlns="" id="{C5E121B9-3BB2-808C-1856-CC06B583F8EE}"/>
               </a:ext>
             </a:extLst>
           </p:cNvPr>
@@ -1005,8 +1012,8 @@
         </p:nvSpPr>
         <p:spPr>
           <a:xfrm>
-            <a:off x="318088" y="2620976"/>
-            <a:ext cx="9254734" cy="1754326"/>
+            <a:off x="318087" y="2620976"/>
+            <a:ext cx="9889400" cy="1754326"/>
           </a:xfrm>
           <a:prstGeom prst="rect">
             <a:avLst/>
@@ -1068,6 +1075,78 @@
               <a:t> Data </a:t>
             </a:r>
             <a:r>
+              <a:rPr lang="en-US" sz="3600" b="1" dirty="0" err="1" smtClean="0">
+                <a:effectLst>
+                  <a:outerShdw blurRad="38100" dist="38100" dir="2700000" algn="tl">
+                    <a:srgbClr val="000000">
+                      <a:alpha val="43137"/>
+                    </a:srgbClr>
+                  </a:outerShdw>
+                </a:effectLst>
+              </a:rPr>
+              <a:t>Geospasial</a:t>
+            </a:r>
+            <a:r>
+              <a:rPr lang="en-US" sz="3600" b="1" dirty="0" smtClean="0">
+                <a:effectLst>
+                  <a:outerShdw blurRad="38100" dist="38100" dir="2700000" algn="tl">
+                    <a:srgbClr val="000000">
+                      <a:alpha val="43137"/>
+                    </a:srgbClr>
+                  </a:outerShdw>
+                </a:effectLst>
+              </a:rPr>
+              <a:t> &amp; Non </a:t>
+            </a:r>
+            <a:r>
+              <a:rPr lang="en-US" sz="3600" b="1" dirty="0" err="1" smtClean="0">
+                <a:effectLst>
+                  <a:outerShdw blurRad="38100" dist="38100" dir="2700000" algn="tl">
+                    <a:srgbClr val="000000">
+                      <a:alpha val="43137"/>
+                    </a:srgbClr>
+                  </a:outerShdw>
+                </a:effectLst>
+              </a:rPr>
+              <a:t>Spasial</a:t>
+            </a:r>
+            <a:r>
+              <a:rPr lang="en-US" sz="3600" b="1" dirty="0" smtClean="0">
+                <a:effectLst>
+                  <a:outerShdw blurRad="38100" dist="38100" dir="2700000" algn="tl">
+                    <a:srgbClr val="000000">
+                      <a:alpha val="43137"/>
+                    </a:srgbClr>
+                  </a:outerShdw>
+                </a:effectLst>
+              </a:rPr>
+              <a:t> (</a:t>
+            </a:r>
+            <a:r>
+              <a:rPr lang="en-US" sz="3600" b="1" dirty="0" err="1" smtClean="0">
+                <a:effectLst>
+                  <a:outerShdw blurRad="38100" dist="38100" dir="2700000" algn="tl">
+                    <a:srgbClr val="000000">
+                      <a:alpha val="43137"/>
+                    </a:srgbClr>
+                  </a:outerShdw>
+                </a:effectLst>
+              </a:rPr>
+              <a:t>Atribut</a:t>
+            </a:r>
+            <a:r>
+              <a:rPr lang="en-US" sz="3600" b="1" dirty="0" smtClean="0">
+                <a:effectLst>
+                  <a:outerShdw blurRad="38100" dist="38100" dir="2700000" algn="tl">
+                    <a:srgbClr val="000000">
+                      <a:alpha val="43137"/>
+                    </a:srgbClr>
+                  </a:outerShdw>
+                </a:effectLst>
+              </a:rPr>
+              <a:t>) </a:t>
+            </a:r>
+            <a:r>
               <a:rPr lang="en-US" sz="3600" b="1" dirty="0" err="1">
                 <a:effectLst>
                   <a:outerShdw blurRad="38100" dist="38100" dir="2700000" algn="tl">
@@ -1077,7 +1156,7 @@
                   </a:outerShdw>
                 </a:effectLst>
               </a:rPr>
-              <a:t>Geospasial</a:t>
+              <a:t>Petani</a:t>
             </a:r>
             <a:r>
               <a:rPr lang="en-US" sz="3600" b="1" dirty="0">
@@ -1101,7 +1180,31 @@
                   </a:outerShdw>
                 </a:effectLst>
               </a:rPr>
-              <a:t>Petani</a:t>
+              <a:t>Pemasok</a:t>
+            </a:r>
+            <a:r>
+              <a:rPr lang="en-US" sz="3600" b="1" dirty="0">
+                <a:effectLst>
+                  <a:outerShdw blurRad="38100" dist="38100" dir="2700000" algn="tl">
+                    <a:srgbClr val="000000">
+                      <a:alpha val="43137"/>
+                    </a:srgbClr>
+                  </a:outerShdw>
+                </a:effectLst>
+              </a:rPr>
+              <a:t> Kelapa </a:t>
+            </a:r>
+            <a:r>
+              <a:rPr lang="en-US" sz="3600" b="1" dirty="0" err="1">
+                <a:effectLst>
+                  <a:outerShdw blurRad="38100" dist="38100" dir="2700000" algn="tl">
+                    <a:srgbClr val="000000">
+                      <a:alpha val="43137"/>
+                    </a:srgbClr>
+                  </a:outerShdw>
+                </a:effectLst>
+              </a:rPr>
+              <a:t>Sawit</a:t>
             </a:r>
             <a:r>
               <a:rPr lang="en-US" sz="3600" b="1" dirty="0">
@@ -1125,31 +1228,7 @@
                   </a:outerShdw>
                 </a:effectLst>
               </a:rPr>
-              <a:t>Pemasok</a:t>
-            </a:r>
-            <a:r>
-              <a:rPr lang="en-US" sz="3600" b="1" dirty="0">
-                <a:effectLst>
-                  <a:outerShdw blurRad="38100" dist="38100" dir="2700000" algn="tl">
-                    <a:srgbClr val="000000">
-                      <a:alpha val="43137"/>
-                    </a:srgbClr>
-                  </a:outerShdw>
-                </a:effectLst>
-              </a:rPr>
-              <a:t> Kelapa </a:t>
-            </a:r>
-            <a:r>
-              <a:rPr lang="en-US" sz="3600" b="1" dirty="0" err="1">
-                <a:effectLst>
-                  <a:outerShdw blurRad="38100" dist="38100" dir="2700000" algn="tl">
-                    <a:srgbClr val="000000">
-                      <a:alpha val="43137"/>
-                    </a:srgbClr>
-                  </a:outerShdw>
-                </a:effectLst>
-              </a:rPr>
-              <a:t>Sawit</a:t>
+              <a:t>untuk</a:t>
             </a:r>
             <a:r>
               <a:rPr lang="en-US" sz="3600" b="1" dirty="0">
@@ -1173,7 +1252,7 @@
                   </a:outerShdw>
                 </a:effectLst>
               </a:rPr>
-              <a:t>untuk</a:t>
+              <a:t>Memenuhi</a:t>
             </a:r>
             <a:r>
               <a:rPr lang="en-US" sz="3600" b="1" dirty="0">
@@ -1188,7 +1267,7 @@
               <a:t> </a:t>
             </a:r>
             <a:r>
-              <a:rPr lang="en-US" sz="3600" b="1" dirty="0" err="1">
+              <a:rPr lang="en-US" sz="3600" b="1" dirty="0" smtClean="0">
                 <a:effectLst>
                   <a:outerShdw blurRad="38100" dist="38100" dir="2700000" algn="tl">
                     <a:srgbClr val="000000">
@@ -1197,7 +1276,7 @@
                   </a:outerShdw>
                 </a:effectLst>
               </a:rPr>
-              <a:t>Memenuhi</a:t>
+              <a:t>Standard </a:t>
             </a:r>
             <a:r>
               <a:rPr lang="en-US" sz="3600" b="1" dirty="0">
@@ -1209,31 +1288,7 @@
                   </a:outerShdw>
                 </a:effectLst>
               </a:rPr>
-              <a:t> </a:t>
-            </a:r>
-            <a:r>
-              <a:rPr lang="en-US" sz="3600" b="1" dirty="0" err="1">
-                <a:effectLst>
-                  <a:outerShdw blurRad="38100" dist="38100" dir="2700000" algn="tl">
-                    <a:srgbClr val="000000">
-                      <a:alpha val="43137"/>
-                    </a:srgbClr>
-                  </a:outerShdw>
-                </a:effectLst>
-              </a:rPr>
-              <a:t>Standar</a:t>
-            </a:r>
-            <a:r>
-              <a:rPr lang="en-US" sz="3600" b="1" dirty="0">
-                <a:effectLst>
-                  <a:outerShdw blurRad="38100" dist="38100" dir="2700000" algn="tl">
-                    <a:srgbClr val="000000">
-                      <a:alpha val="43137"/>
-                    </a:srgbClr>
-                  </a:outerShdw>
-                </a:effectLst>
-              </a:rPr>
-              <a:t> EUDR di PT. AAPA</a:t>
+              <a:t>EUDR di PT. AAPA</a:t>
             </a:r>
             <a:endParaRPr lang="en-US" sz="3600" b="1" dirty="0">
               <a:effectLst>
@@ -1284,7 +1339,7 @@
           <p:cNvPr id="4" name="Title 3">
             <a:extLst>
               <a:ext uri="{FF2B5EF4-FFF2-40B4-BE49-F238E27FC236}">
-                <a16:creationId xmlns:a16="http://schemas.microsoft.com/office/drawing/2014/main" id="{54C42B0D-A49E-4494-2844-6E806755AE4B}"/>
+                <a16:creationId xmlns:a16="http://schemas.microsoft.com/office/drawing/2014/main" xmlns="" id="{54C42B0D-A49E-4494-2844-6E806755AE4B}"/>
               </a:ext>
             </a:extLst>
           </p:cNvPr>
@@ -1350,7 +1405,7 @@
           <p:cNvPr id="59" name="Freeform: Shape 58">
             <a:extLst>
               <a:ext uri="{FF2B5EF4-FFF2-40B4-BE49-F238E27FC236}">
-                <a16:creationId xmlns:a16="http://schemas.microsoft.com/office/drawing/2014/main" id="{0D1E4732-8A6C-6156-A6F6-292864F30D35}"/>
+                <a16:creationId xmlns:a16="http://schemas.microsoft.com/office/drawing/2014/main" xmlns="" id="{0D1E4732-8A6C-6156-A6F6-292864F30D35}"/>
               </a:ext>
             </a:extLst>
           </p:cNvPr>
@@ -1479,7 +1534,7 @@
           <p:cNvPr id="60" name="Freeform: Shape 59">
             <a:extLst>
               <a:ext uri="{FF2B5EF4-FFF2-40B4-BE49-F238E27FC236}">
-                <a16:creationId xmlns:a16="http://schemas.microsoft.com/office/drawing/2014/main" id="{93932919-510E-BFB7-837C-BF460BC46AF1}"/>
+                <a16:creationId xmlns:a16="http://schemas.microsoft.com/office/drawing/2014/main" xmlns="" id="{93932919-510E-BFB7-837C-BF460BC46AF1}"/>
               </a:ext>
             </a:extLst>
           </p:cNvPr>
@@ -1808,7 +1863,7 @@
           <p:cNvPr id="61" name="Freeform: Shape 60">
             <a:extLst>
               <a:ext uri="{FF2B5EF4-FFF2-40B4-BE49-F238E27FC236}">
-                <a16:creationId xmlns:a16="http://schemas.microsoft.com/office/drawing/2014/main" id="{840204E5-D140-9404-8664-CC0C18ECA4FC}"/>
+                <a16:creationId xmlns:a16="http://schemas.microsoft.com/office/drawing/2014/main" xmlns="" id="{840204E5-D140-9404-8664-CC0C18ECA4FC}"/>
               </a:ext>
             </a:extLst>
           </p:cNvPr>
@@ -1938,7 +1993,7 @@
           <p:cNvPr id="62" name="Freeform: Shape 61">
             <a:extLst>
               <a:ext uri="{FF2B5EF4-FFF2-40B4-BE49-F238E27FC236}">
-                <a16:creationId xmlns:a16="http://schemas.microsoft.com/office/drawing/2014/main" id="{6AFC1A22-A928-384C-97B9-A1A4CFCF8669}"/>
+                <a16:creationId xmlns:a16="http://schemas.microsoft.com/office/drawing/2014/main" xmlns="" id="{6AFC1A22-A928-384C-97B9-A1A4CFCF8669}"/>
               </a:ext>
             </a:extLst>
           </p:cNvPr>
@@ -2155,7 +2210,7 @@
           <p:cNvPr id="63" name="Freeform: Shape 62">
             <a:extLst>
               <a:ext uri="{FF2B5EF4-FFF2-40B4-BE49-F238E27FC236}">
-                <a16:creationId xmlns:a16="http://schemas.microsoft.com/office/drawing/2014/main" id="{22BD85BA-E0EE-0727-58E3-710FC9456BC3}"/>
+                <a16:creationId xmlns:a16="http://schemas.microsoft.com/office/drawing/2014/main" xmlns="" id="{22BD85BA-E0EE-0727-58E3-710FC9456BC3}"/>
               </a:ext>
             </a:extLst>
           </p:cNvPr>
@@ -2284,7 +2339,7 @@
           <p:cNvPr id="64" name="Freeform: Shape 63">
             <a:extLst>
               <a:ext uri="{FF2B5EF4-FFF2-40B4-BE49-F238E27FC236}">
-                <a16:creationId xmlns:a16="http://schemas.microsoft.com/office/drawing/2014/main" id="{8C0A7FB5-45F1-C2E5-0C3C-A7A90F4B7F2C}"/>
+                <a16:creationId xmlns:a16="http://schemas.microsoft.com/office/drawing/2014/main" xmlns="" id="{8C0A7FB5-45F1-C2E5-0C3C-A7A90F4B7F2C}"/>
               </a:ext>
             </a:extLst>
           </p:cNvPr>
@@ -2483,7 +2538,7 @@
           <p:cNvPr id="65" name="Freeform: Shape 64">
             <a:extLst>
               <a:ext uri="{FF2B5EF4-FFF2-40B4-BE49-F238E27FC236}">
-                <a16:creationId xmlns:a16="http://schemas.microsoft.com/office/drawing/2014/main" id="{F29D7F72-A7D7-5C28-885C-D48692393F25}"/>
+                <a16:creationId xmlns:a16="http://schemas.microsoft.com/office/drawing/2014/main" xmlns="" id="{F29D7F72-A7D7-5C28-885C-D48692393F25}"/>
               </a:ext>
             </a:extLst>
           </p:cNvPr>
@@ -2616,7 +2671,7 @@
           <p:cNvPr id="67" name="Picture 417" descr="icon-tree-palm.gif">
             <a:extLst>
               <a:ext uri="{FF2B5EF4-FFF2-40B4-BE49-F238E27FC236}">
-                <a16:creationId xmlns:a16="http://schemas.microsoft.com/office/drawing/2014/main" id="{D08DC7F0-AE0E-E99B-5F64-211B549E97E9}"/>
+                <a16:creationId xmlns:a16="http://schemas.microsoft.com/office/drawing/2014/main" xmlns="" id="{D08DC7F0-AE0E-E99B-5F64-211B549E97E9}"/>
               </a:ext>
             </a:extLst>
           </p:cNvPr>
@@ -2676,7 +2731,7 @@
           <p:cNvPr id="68" name="Picture 417" descr="icon-tree-palm.gif">
             <a:extLst>
               <a:ext uri="{FF2B5EF4-FFF2-40B4-BE49-F238E27FC236}">
-                <a16:creationId xmlns:a16="http://schemas.microsoft.com/office/drawing/2014/main" id="{ADBD89E8-3F7E-65B9-3224-71560B625FD8}"/>
+                <a16:creationId xmlns:a16="http://schemas.microsoft.com/office/drawing/2014/main" xmlns="" id="{ADBD89E8-3F7E-65B9-3224-71560B625FD8}"/>
               </a:ext>
             </a:extLst>
           </p:cNvPr>
@@ -2736,7 +2791,7 @@
           <p:cNvPr id="122" name="Table 121">
             <a:extLst>
               <a:ext uri="{FF2B5EF4-FFF2-40B4-BE49-F238E27FC236}">
-                <a16:creationId xmlns:a16="http://schemas.microsoft.com/office/drawing/2014/main" id="{EFB29C21-FA35-A16C-06F9-C702636D2FA0}"/>
+                <a16:creationId xmlns:a16="http://schemas.microsoft.com/office/drawing/2014/main" xmlns="" id="{EFB29C21-FA35-A16C-06F9-C702636D2FA0}"/>
               </a:ext>
             </a:extLst>
           </p:cNvPr>
@@ -2765,7 +2820,7 @@
                 <a:gridCol w="8592584">
                   <a:extLst>
                     <a:ext uri="{9D8B030D-6E8A-4147-A177-3AD203B41FA5}">
-                      <a16:colId xmlns:a16="http://schemas.microsoft.com/office/drawing/2014/main" val="576300811"/>
+                      <a16:colId xmlns:a16="http://schemas.microsoft.com/office/drawing/2014/main" xmlns="" val="576300811"/>
                     </a:ext>
                   </a:extLst>
                 </a:gridCol>
@@ -2794,7 +2849,7 @@
                 </a:tc>
                 <a:extLst>
                   <a:ext uri="{0D108BD9-81ED-4DB2-BD59-A6C34878D82A}">
-                    <a16:rowId xmlns:a16="http://schemas.microsoft.com/office/drawing/2014/main" val="358469398"/>
+                    <a16:rowId xmlns:a16="http://schemas.microsoft.com/office/drawing/2014/main" xmlns="" val="358469398"/>
                   </a:ext>
                 </a:extLst>
               </a:tr>
@@ -3163,7 +3218,7 @@
                 </a:tc>
                 <a:extLst>
                   <a:ext uri="{0D108BD9-81ED-4DB2-BD59-A6C34878D82A}">
-                    <a16:rowId xmlns:a16="http://schemas.microsoft.com/office/drawing/2014/main" val="2387879687"/>
+                    <a16:rowId xmlns:a16="http://schemas.microsoft.com/office/drawing/2014/main" xmlns="" val="2387879687"/>
                   </a:ext>
                 </a:extLst>
               </a:tr>
@@ -3176,7 +3231,7 @@
           <p:cNvPr id="6" name="Group 5">
             <a:extLst>
               <a:ext uri="{FF2B5EF4-FFF2-40B4-BE49-F238E27FC236}">
-                <a16:creationId xmlns:a16="http://schemas.microsoft.com/office/drawing/2014/main" id="{29101635-D14A-D0AC-10DB-C291E6C62397}"/>
+                <a16:creationId xmlns:a16="http://schemas.microsoft.com/office/drawing/2014/main" xmlns="" id="{29101635-D14A-D0AC-10DB-C291E6C62397}"/>
               </a:ext>
             </a:extLst>
           </p:cNvPr>
@@ -3196,7 +3251,7 @@
             <p:cNvPr id="3" name="Picture 2" descr="A picture containing map, world&#10;&#10;Description automatically generated">
               <a:extLst>
                 <a:ext uri="{FF2B5EF4-FFF2-40B4-BE49-F238E27FC236}">
-                  <a16:creationId xmlns:a16="http://schemas.microsoft.com/office/drawing/2014/main" id="{3E93BDD9-AFE9-B8EC-4237-E8082B5AD719}"/>
+                  <a16:creationId xmlns:a16="http://schemas.microsoft.com/office/drawing/2014/main" xmlns="" id="{3E93BDD9-AFE9-B8EC-4237-E8082B5AD719}"/>
                 </a:ext>
               </a:extLst>
             </p:cNvPr>
@@ -3250,7 +3305,7 @@
             <p:cNvPr id="121" name="Oval 120">
               <a:extLst>
                 <a:ext uri="{FF2B5EF4-FFF2-40B4-BE49-F238E27FC236}">
-                  <a16:creationId xmlns:a16="http://schemas.microsoft.com/office/drawing/2014/main" id="{CC21299D-F4A9-4C53-350E-33844FA29F5E}"/>
+                  <a16:creationId xmlns:a16="http://schemas.microsoft.com/office/drawing/2014/main" xmlns="" id="{CC21299D-F4A9-4C53-350E-33844FA29F5E}"/>
                 </a:ext>
               </a:extLst>
             </p:cNvPr>
@@ -3301,7 +3356,7 @@
             <p:cNvPr id="17" name="Oval 16">
               <a:extLst>
                 <a:ext uri="{FF2B5EF4-FFF2-40B4-BE49-F238E27FC236}">
-                  <a16:creationId xmlns:a16="http://schemas.microsoft.com/office/drawing/2014/main" id="{622C7297-7002-2EC3-CF18-B339F681DDDB}"/>
+                  <a16:creationId xmlns:a16="http://schemas.microsoft.com/office/drawing/2014/main" xmlns="" id="{622C7297-7002-2EC3-CF18-B339F681DDDB}"/>
                 </a:ext>
               </a:extLst>
             </p:cNvPr>
@@ -3352,7 +3407,7 @@
             <p:cNvPr id="20" name="Oval 19">
               <a:extLst>
                 <a:ext uri="{FF2B5EF4-FFF2-40B4-BE49-F238E27FC236}">
-                  <a16:creationId xmlns:a16="http://schemas.microsoft.com/office/drawing/2014/main" id="{FE3A288B-ABC7-09F2-A6C0-619797C83778}"/>
+                  <a16:creationId xmlns:a16="http://schemas.microsoft.com/office/drawing/2014/main" xmlns="" id="{FE3A288B-ABC7-09F2-A6C0-619797C83778}"/>
                 </a:ext>
               </a:extLst>
             </p:cNvPr>
@@ -3403,7 +3458,7 @@
             <p:cNvPr id="23" name="Oval 22">
               <a:extLst>
                 <a:ext uri="{FF2B5EF4-FFF2-40B4-BE49-F238E27FC236}">
-                  <a16:creationId xmlns:a16="http://schemas.microsoft.com/office/drawing/2014/main" id="{CA70FB2A-92CB-BDCB-7987-1A461AAE9072}"/>
+                  <a16:creationId xmlns:a16="http://schemas.microsoft.com/office/drawing/2014/main" xmlns="" id="{CA70FB2A-92CB-BDCB-7987-1A461AAE9072}"/>
                 </a:ext>
               </a:extLst>
             </p:cNvPr>
@@ -3455,7 +3510,7 @@
           <p:cNvPr id="5" name="Straight Connector 4">
             <a:extLst>
               <a:ext uri="{FF2B5EF4-FFF2-40B4-BE49-F238E27FC236}">
-                <a16:creationId xmlns:a16="http://schemas.microsoft.com/office/drawing/2014/main" id="{A8A864D2-69A8-A6F5-DDA4-8574175295C9}"/>
+                <a16:creationId xmlns:a16="http://schemas.microsoft.com/office/drawing/2014/main" xmlns="" id="{A8A864D2-69A8-A6F5-DDA4-8574175295C9}"/>
               </a:ext>
             </a:extLst>
           </p:cNvPr>
@@ -3492,7 +3547,7 @@
           <p:cNvPr id="125" name="Connector: Elbow 124">
             <a:extLst>
               <a:ext uri="{FF2B5EF4-FFF2-40B4-BE49-F238E27FC236}">
-                <a16:creationId xmlns:a16="http://schemas.microsoft.com/office/drawing/2014/main" id="{DC46A14B-0613-E160-CC4B-F25921EDE7E3}"/>
+                <a16:creationId xmlns:a16="http://schemas.microsoft.com/office/drawing/2014/main" xmlns="" id="{DC46A14B-0613-E160-CC4B-F25921EDE7E3}"/>
               </a:ext>
             </a:extLst>
           </p:cNvPr>
@@ -3537,7 +3592,7 @@
           <p:cNvPr id="73" name="Connector: Elbow 72">
             <a:extLst>
               <a:ext uri="{FF2B5EF4-FFF2-40B4-BE49-F238E27FC236}">
-                <a16:creationId xmlns:a16="http://schemas.microsoft.com/office/drawing/2014/main" id="{86763F97-08FB-A872-DE72-C507A1E89583}"/>
+                <a16:creationId xmlns:a16="http://schemas.microsoft.com/office/drawing/2014/main" xmlns="" id="{86763F97-08FB-A872-DE72-C507A1E89583}"/>
               </a:ext>
             </a:extLst>
           </p:cNvPr>
@@ -3584,7 +3639,7 @@
           <p:cNvPr id="82" name="Connector: Elbow 81">
             <a:extLst>
               <a:ext uri="{FF2B5EF4-FFF2-40B4-BE49-F238E27FC236}">
-                <a16:creationId xmlns:a16="http://schemas.microsoft.com/office/drawing/2014/main" id="{5551805F-D117-561B-00AC-77C7AA53FBE8}"/>
+                <a16:creationId xmlns:a16="http://schemas.microsoft.com/office/drawing/2014/main" xmlns="" id="{5551805F-D117-561B-00AC-77C7AA53FBE8}"/>
               </a:ext>
             </a:extLst>
           </p:cNvPr>
@@ -3630,7 +3685,7 @@
           <p:cNvPr id="10" name="Straight Connector 9">
             <a:extLst>
               <a:ext uri="{FF2B5EF4-FFF2-40B4-BE49-F238E27FC236}">
-                <a16:creationId xmlns:a16="http://schemas.microsoft.com/office/drawing/2014/main" id="{C5A62F0C-8D46-D575-F7CB-5137A7FE4648}"/>
+                <a16:creationId xmlns:a16="http://schemas.microsoft.com/office/drawing/2014/main" xmlns="" id="{C5A62F0C-8D46-D575-F7CB-5137A7FE4648}"/>
               </a:ext>
             </a:extLst>
           </p:cNvPr>
@@ -3673,7 +3728,7 @@
           <p:cNvPr id="58" name="Freeform: Shape 57">
             <a:extLst>
               <a:ext uri="{FF2B5EF4-FFF2-40B4-BE49-F238E27FC236}">
-                <a16:creationId xmlns:a16="http://schemas.microsoft.com/office/drawing/2014/main" id="{0F649A41-073C-6C1E-5169-9A7A16B298A3}"/>
+                <a16:creationId xmlns:a16="http://schemas.microsoft.com/office/drawing/2014/main" xmlns="" id="{0F649A41-073C-6C1E-5169-9A7A16B298A3}"/>
               </a:ext>
             </a:extLst>
           </p:cNvPr>
@@ -3865,7 +3920,7 @@
           <p:cNvPr id="66" name="Picture 417" descr="icon-tree-palm.gif">
             <a:extLst>
               <a:ext uri="{FF2B5EF4-FFF2-40B4-BE49-F238E27FC236}">
-                <a16:creationId xmlns:a16="http://schemas.microsoft.com/office/drawing/2014/main" id="{8CCB2A4E-CC4C-AAF6-C4AE-FADA88A5A845}"/>
+                <a16:creationId xmlns:a16="http://schemas.microsoft.com/office/drawing/2014/main" xmlns="" id="{8CCB2A4E-CC4C-AAF6-C4AE-FADA88A5A845}"/>
               </a:ext>
             </a:extLst>
           </p:cNvPr>
@@ -3925,7 +3980,7 @@
           <p:cNvPr id="88" name="Connector: Elbow 87">
             <a:extLst>
               <a:ext uri="{FF2B5EF4-FFF2-40B4-BE49-F238E27FC236}">
-                <a16:creationId xmlns:a16="http://schemas.microsoft.com/office/drawing/2014/main" id="{D5A1F867-6148-9776-D8F9-0A4CD3D2AE0B}"/>
+                <a16:creationId xmlns:a16="http://schemas.microsoft.com/office/drawing/2014/main" xmlns="" id="{D5A1F867-6148-9776-D8F9-0A4CD3D2AE0B}"/>
               </a:ext>
             </a:extLst>
           </p:cNvPr>
@@ -3988,7 +4043,7 @@
         <p:cNvPr id="1" name="">
           <a:extLst>
             <a:ext uri="{FF2B5EF4-FFF2-40B4-BE49-F238E27FC236}">
-              <a16:creationId xmlns:a16="http://schemas.microsoft.com/office/drawing/2014/main" id="{529319B4-3699-A9DA-BEF0-436AF3936DEB}"/>
+              <a16:creationId xmlns:a16="http://schemas.microsoft.com/office/drawing/2014/main" xmlns="" id="{529319B4-3699-A9DA-BEF0-436AF3936DEB}"/>
             </a:ext>
           </a:extLst>
         </p:cNvPr>
@@ -4008,7 +4063,7 @@
           <p:cNvPr id="4" name="Title 3">
             <a:extLst>
               <a:ext uri="{FF2B5EF4-FFF2-40B4-BE49-F238E27FC236}">
-                <a16:creationId xmlns:a16="http://schemas.microsoft.com/office/drawing/2014/main" id="{8AA798A0-E6D2-25D3-EAF2-DF5D56DBE632}"/>
+                <a16:creationId xmlns:a16="http://schemas.microsoft.com/office/drawing/2014/main" xmlns="" id="{8AA798A0-E6D2-25D3-EAF2-DF5D56DBE632}"/>
               </a:ext>
             </a:extLst>
           </p:cNvPr>
@@ -4340,7 +4395,7 @@
           <a:blip>
             <a:extLst>
               <a:ext uri="{96DAC541-7B7A-43D3-8B79-37D633B846F1}">
-                <asvg:svgBlip xmlns:asvg="http://schemas.microsoft.com/office/drawing/2016/SVG/main" r:embed="rId2"/>
+                <asvg:svgBlip xmlns:asvg="http://schemas.microsoft.com/office/drawing/2016/SVG/main" xmlns="" r:embed="rId2"/>
               </a:ext>
             </a:extLst>
           </a:blip>
@@ -4370,7 +4425,7 @@
           <a:blip>
             <a:extLst>
               <a:ext uri="{96DAC541-7B7A-43D3-8B79-37D633B846F1}">
-                <asvg:svgBlip xmlns:asvg="http://schemas.microsoft.com/office/drawing/2016/SVG/main" r:embed="rId3"/>
+                <asvg:svgBlip xmlns:asvg="http://schemas.microsoft.com/office/drawing/2016/SVG/main" xmlns="" r:embed="rId3"/>
               </a:ext>
             </a:extLst>
           </a:blip>
@@ -4393,7 +4448,7 @@
           <p:cNvPr id="3" name="Picture 2">
             <a:extLst>
               <a:ext uri="{FF2B5EF4-FFF2-40B4-BE49-F238E27FC236}">
-                <a16:creationId xmlns:a16="http://schemas.microsoft.com/office/drawing/2014/main" id="{984CAB20-7572-AED7-BF28-56F7047C46E5}"/>
+                <a16:creationId xmlns:a16="http://schemas.microsoft.com/office/drawing/2014/main" xmlns="" id="{984CAB20-7572-AED7-BF28-56F7047C46E5}"/>
               </a:ext>
             </a:extLst>
           </p:cNvPr>
@@ -4423,7 +4478,7 @@
           <p:cNvPr id="6" name="Picture 5">
             <a:extLst>
               <a:ext uri="{FF2B5EF4-FFF2-40B4-BE49-F238E27FC236}">
-                <a16:creationId xmlns:a16="http://schemas.microsoft.com/office/drawing/2014/main" id="{C0AE187C-63E9-81EE-11BD-B57586997B8C}"/>
+                <a16:creationId xmlns:a16="http://schemas.microsoft.com/office/drawing/2014/main" xmlns="" id="{C0AE187C-63E9-81EE-11BD-B57586997B8C}"/>
               </a:ext>
             </a:extLst>
           </p:cNvPr>
@@ -4469,7 +4524,7 @@
         <p:cNvPr id="1" name="">
           <a:extLst>
             <a:ext uri="{FF2B5EF4-FFF2-40B4-BE49-F238E27FC236}">
-              <a16:creationId xmlns:a16="http://schemas.microsoft.com/office/drawing/2014/main" id="{51876B17-CDFA-6737-BED8-47F1A490D4F1}"/>
+              <a16:creationId xmlns:a16="http://schemas.microsoft.com/office/drawing/2014/main" xmlns="" id="{51876B17-CDFA-6737-BED8-47F1A490D4F1}"/>
             </a:ext>
           </a:extLst>
         </p:cNvPr>
@@ -4489,7 +4544,7 @@
           <p:cNvPr id="2" name="Title 1">
             <a:extLst>
               <a:ext uri="{FF2B5EF4-FFF2-40B4-BE49-F238E27FC236}">
-                <a16:creationId xmlns:a16="http://schemas.microsoft.com/office/drawing/2014/main" id="{480EF453-204A-03B4-1C17-9DE07092408C}"/>
+                <a16:creationId xmlns:a16="http://schemas.microsoft.com/office/drawing/2014/main" xmlns="" id="{480EF453-204A-03B4-1C17-9DE07092408C}"/>
               </a:ext>
             </a:extLst>
           </p:cNvPr>
@@ -4500,7 +4555,7 @@
         </p:nvSpPr>
         <p:spPr>
           <a:xfrm>
-            <a:off x="3902493" y="378657"/>
+            <a:off x="3365780" y="378657"/>
             <a:ext cx="8177890" cy="791198"/>
           </a:xfrm>
           <a:prstGeom prst="rect">
@@ -4533,13 +4588,14 @@
           <a:p>
             <a:pPr algn="r"/>
             <a:r>
-              <a:rPr lang="en-US" dirty="0" err="1"/>
+              <a:rPr lang="en-US" b="1" dirty="0" err="1" smtClean="0"/>
               <a:t>Profil</a:t>
             </a:r>
             <a:r>
-              <a:rPr lang="en-US" dirty="0"/>
-              <a:t> PT.ANUGERAH ABADI PRIMA AGUNG</a:t>
-            </a:r>
+              <a:rPr lang="en-US" b="1" dirty="0" smtClean="0"/>
+              <a:t> PT. ANUGERAH AGUNG PRIMA ABADI</a:t>
+            </a:r>
+            <a:endParaRPr lang="en-US" b="1" dirty="0"/>
           </a:p>
         </p:txBody>
       </p:sp>
@@ -4548,7 +4604,7 @@
           <p:cNvPr id="3" name="TextBox 2">
             <a:extLst>
               <a:ext uri="{FF2B5EF4-FFF2-40B4-BE49-F238E27FC236}">
-                <a16:creationId xmlns:a16="http://schemas.microsoft.com/office/drawing/2014/main" id="{3C6EA773-A85D-A4BE-5357-A36FA3991003}"/>
+                <a16:creationId xmlns:a16="http://schemas.microsoft.com/office/drawing/2014/main" xmlns="" id="{3C6EA773-A85D-A4BE-5357-A36FA3991003}"/>
               </a:ext>
             </a:extLst>
           </p:cNvPr>
@@ -4557,8 +4613,8 @@
         </p:nvSpPr>
         <p:spPr>
           <a:xfrm>
-            <a:off x="244734" y="1313667"/>
-            <a:ext cx="11468675" cy="1969766"/>
+            <a:off x="244734" y="1462753"/>
+            <a:ext cx="11468675" cy="2092877"/>
           </a:xfrm>
           <a:prstGeom prst="rect">
             <a:avLst/>
@@ -4611,7 +4667,7 @@
               <a:t>Nama Perusahaan		:  </a:t>
             </a:r>
             <a:r>
-              <a:rPr kumimoji="0" lang="en-US" sz="2400" i="0" u="none" strike="noStrike" kern="0" cap="none" spc="0" normalizeH="0" baseline="0" noProof="0" dirty="0">
+              <a:rPr kumimoji="0" lang="en-US" sz="1600" i="0" u="none" strike="noStrike" kern="0" cap="none" spc="0" normalizeH="0" baseline="0" noProof="0" dirty="0">
                 <a:ln>
                   <a:noFill/>
                 </a:ln>
@@ -4633,7 +4689,7 @@
               <a:t>PT. </a:t>
             </a:r>
             <a:r>
-              <a:rPr kumimoji="0" lang="en-US" sz="2400" i="0" u="none" strike="noStrike" kern="0" cap="none" spc="0" normalizeH="0" baseline="0" noProof="0" dirty="0" err="1">
+              <a:rPr kumimoji="0" lang="en-US" sz="1600" i="0" u="none" strike="noStrike" kern="0" cap="none" spc="0" normalizeH="0" baseline="0" noProof="0" dirty="0" err="1">
                 <a:ln>
                   <a:noFill/>
                 </a:ln>
@@ -4655,7 +4711,7 @@
               <a:t>Anugerah</a:t>
             </a:r>
             <a:r>
-              <a:rPr kumimoji="0" lang="en-US" sz="2400" i="0" u="none" strike="noStrike" kern="0" cap="none" spc="0" normalizeH="0" baseline="0" noProof="0" dirty="0">
+              <a:rPr kumimoji="0" lang="en-US" sz="1600" i="0" u="none" strike="noStrike" kern="0" cap="none" spc="0" normalizeH="0" baseline="0" noProof="0" dirty="0">
                 <a:ln>
                   <a:noFill/>
                 </a:ln>
@@ -4674,7 +4730,73 @@
                 <a:latin typeface="+mn-lt"/>
                 <a:cs typeface="Calibri" pitchFamily="34" charset="0"/>
               </a:rPr>
-              <a:t> Abadi Prima Agung</a:t>
+              <a:t> </a:t>
+            </a:r>
+            <a:r>
+              <a:rPr kumimoji="0" lang="en-US" sz="1600" i="0" u="none" strike="noStrike" kern="0" cap="none" spc="0" normalizeH="0" baseline="0" noProof="0" dirty="0" err="1" smtClean="0">
+                <a:ln>
+                  <a:noFill/>
+                </a:ln>
+                <a:solidFill>
+                  <a:srgbClr val="000000"/>
+                </a:solidFill>
+                <a:effectLst>
+                  <a:outerShdw blurRad="38100" dist="38100" dir="2700000" algn="tl">
+                    <a:srgbClr val="000000">
+                      <a:alpha val="43137"/>
+                    </a:srgbClr>
+                  </a:outerShdw>
+                </a:effectLst>
+                <a:uLnTx/>
+                <a:uFillTx/>
+                <a:latin typeface="+mn-lt"/>
+                <a:cs typeface="Calibri" pitchFamily="34" charset="0"/>
+              </a:rPr>
+              <a:t>Agung</a:t>
+            </a:r>
+            <a:r>
+              <a:rPr kumimoji="0" lang="en-US" sz="1600" i="0" u="none" strike="noStrike" kern="0" cap="none" spc="0" normalizeH="0" baseline="0" noProof="0" dirty="0" smtClean="0">
+                <a:ln>
+                  <a:noFill/>
+                </a:ln>
+                <a:solidFill>
+                  <a:srgbClr val="000000"/>
+                </a:solidFill>
+                <a:effectLst>
+                  <a:outerShdw blurRad="38100" dist="38100" dir="2700000" algn="tl">
+                    <a:srgbClr val="000000">
+                      <a:alpha val="43137"/>
+                    </a:srgbClr>
+                  </a:outerShdw>
+                </a:effectLst>
+                <a:uLnTx/>
+                <a:uFillTx/>
+                <a:latin typeface="+mn-lt"/>
+                <a:cs typeface="Calibri" pitchFamily="34" charset="0"/>
+              </a:rPr>
+              <a:t> Prima </a:t>
+            </a:r>
+            <a:r>
+              <a:rPr kumimoji="0" lang="en-US" sz="1600" i="0" u="none" strike="noStrike" kern="0" cap="none" spc="0" normalizeH="0" baseline="0" noProof="0" dirty="0" err="1" smtClean="0">
+                <a:ln>
+                  <a:noFill/>
+                </a:ln>
+                <a:solidFill>
+                  <a:srgbClr val="000000"/>
+                </a:solidFill>
+                <a:effectLst>
+                  <a:outerShdw blurRad="38100" dist="38100" dir="2700000" algn="tl">
+                    <a:srgbClr val="000000">
+                      <a:alpha val="43137"/>
+                    </a:srgbClr>
+                  </a:outerShdw>
+                </a:effectLst>
+                <a:uLnTx/>
+                <a:uFillTx/>
+                <a:latin typeface="+mn-lt"/>
+                <a:cs typeface="Calibri" pitchFamily="34" charset="0"/>
+              </a:rPr>
+              <a:t>Abadi</a:t>
             </a:r>
             <a:endParaRPr kumimoji="0" lang="en-US" sz="1600" i="0" u="none" strike="noStrike" kern="0" cap="none" spc="0" normalizeH="0" baseline="0" noProof="0" dirty="0">
               <a:ln>
@@ -4728,10 +4850,10 @@
                 <a:latin typeface="+mn-lt"/>
                 <a:cs typeface="Calibri" pitchFamily="34" charset="0"/>
               </a:rPr>
-              <a:t>Alamat			:  Kampung </a:t>
-            </a:r>
-            <a:r>
-              <a:rPr kumimoji="0" lang="en-US" sz="1600" i="0" u="none" strike="noStrike" kern="0" cap="none" spc="0" normalizeH="0" baseline="0" noProof="0" dirty="0" err="1">
+              <a:t>Alamat			:  </a:t>
+            </a:r>
+            <a:r>
+              <a:rPr kumimoji="0" lang="en-US" sz="1600" b="1" i="0" u="none" strike="noStrike" kern="0" cap="none" spc="0" normalizeH="0" baseline="0" noProof="0" dirty="0">
                 <a:ln>
                   <a:noFill/>
                 </a:ln>
@@ -4741,58 +4863,12 @@
                 <a:effectLst/>
                 <a:uLnTx/>
                 <a:uFillTx/>
-                <a:latin typeface="+mn-lt"/>
                 <a:cs typeface="Calibri" pitchFamily="34" charset="0"/>
               </a:rPr>
-              <a:t>Merapun</a:t>
-            </a:r>
-            <a:r>
-              <a:rPr lang="en-US" sz="1600" kern="0" dirty="0">
-                <a:solidFill>
-                  <a:srgbClr val="000000"/>
-                </a:solidFill>
-                <a:cs typeface="Calibri" pitchFamily="34" charset="0"/>
-              </a:rPr>
-              <a:t>, </a:t>
-            </a:r>
-            <a:r>
-              <a:rPr lang="en-US" sz="1600" kern="0" dirty="0" err="1">
-                <a:solidFill>
-                  <a:srgbClr val="000000"/>
-                </a:solidFill>
-                <a:cs typeface="Calibri" pitchFamily="34" charset="0"/>
-              </a:rPr>
-              <a:t>Kec</a:t>
-            </a:r>
-            <a:r>
-              <a:rPr lang="en-US" sz="1600" kern="0" dirty="0">
-                <a:solidFill>
-                  <a:srgbClr val="000000"/>
-                </a:solidFill>
-                <a:cs typeface="Calibri" pitchFamily="34" charset="0"/>
-              </a:rPr>
-              <a:t>. Kelai </a:t>
-            </a:r>
-            <a:r>
-              <a:rPr lang="en-US" sz="1600" kern="0" dirty="0" err="1">
-                <a:solidFill>
-                  <a:srgbClr val="000000"/>
-                </a:solidFill>
-                <a:cs typeface="Calibri" pitchFamily="34" charset="0"/>
-              </a:rPr>
-              <a:t>Kab</a:t>
-            </a:r>
-            <a:r>
-              <a:rPr lang="en-US" sz="1600" kern="0" dirty="0">
-                <a:solidFill>
-                  <a:srgbClr val="000000"/>
-                </a:solidFill>
-                <a:cs typeface="Calibri" pitchFamily="34" charset="0"/>
-              </a:rPr>
-              <a:t>.</a:t>
-            </a:r>
-            <a:r>
-              <a:rPr kumimoji="0" lang="en-US" sz="1600" i="0" u="none" strike="noStrike" kern="0" cap="none" spc="0" normalizeH="0" baseline="0" noProof="0" dirty="0">
+              <a:t>Kampung </a:t>
+            </a:r>
+            <a:r>
+              <a:rPr kumimoji="0" lang="en-US" sz="1600" b="1" i="0" u="none" strike="noStrike" kern="0" cap="none" spc="0" normalizeH="0" baseline="0" noProof="0" dirty="0" err="1">
                 <a:ln>
                   <a:noFill/>
                 </a:ln>
@@ -4802,13 +4878,75 @@
                 <a:effectLst/>
                 <a:uLnTx/>
                 <a:uFillTx/>
-                <a:latin typeface="+mn-lt"/>
                 <a:cs typeface="Calibri" pitchFamily="34" charset="0"/>
               </a:rPr>
-              <a:t> </a:t>
-            </a:r>
-            <a:r>
-              <a:rPr kumimoji="0" lang="en-US" sz="1600" i="0" u="none" strike="noStrike" kern="0" cap="none" spc="0" normalizeH="0" baseline="0" noProof="0" dirty="0" err="1">
+              <a:t>Merapun</a:t>
+            </a:r>
+            <a:r>
+              <a:rPr lang="en-US" sz="1600" b="1" kern="0" dirty="0">
+                <a:solidFill>
+                  <a:srgbClr val="000000"/>
+                </a:solidFill>
+                <a:cs typeface="Calibri" pitchFamily="34" charset="0"/>
+              </a:rPr>
+              <a:t>, </a:t>
+            </a:r>
+            <a:r>
+              <a:rPr lang="en-US" sz="1600" b="1" kern="0" dirty="0" err="1">
+                <a:solidFill>
+                  <a:srgbClr val="000000"/>
+                </a:solidFill>
+                <a:cs typeface="Calibri" pitchFamily="34" charset="0"/>
+              </a:rPr>
+              <a:t>Kec</a:t>
+            </a:r>
+            <a:r>
+              <a:rPr lang="en-US" sz="1600" b="1" kern="0" dirty="0">
+                <a:solidFill>
+                  <a:srgbClr val="000000"/>
+                </a:solidFill>
+                <a:cs typeface="Calibri" pitchFamily="34" charset="0"/>
+              </a:rPr>
+              <a:t>. </a:t>
+            </a:r>
+            <a:r>
+              <a:rPr lang="en-US" sz="1600" b="1" kern="0" dirty="0" err="1" smtClean="0">
+                <a:solidFill>
+                  <a:srgbClr val="000000"/>
+                </a:solidFill>
+                <a:cs typeface="Calibri" pitchFamily="34" charset="0"/>
+              </a:rPr>
+              <a:t>Kelay</a:t>
+            </a:r>
+            <a:r>
+              <a:rPr lang="en-US" sz="1600" b="1" kern="0" dirty="0" smtClean="0">
+                <a:solidFill>
+                  <a:srgbClr val="000000"/>
+                </a:solidFill>
+                <a:cs typeface="Calibri" pitchFamily="34" charset="0"/>
+              </a:rPr>
+              <a:t>, </a:t>
+            </a:r>
+            <a:r>
+              <a:rPr lang="en-US" sz="1600" b="1" kern="0" dirty="0" err="1">
+                <a:solidFill>
+                  <a:srgbClr val="000000"/>
+                </a:solidFill>
+                <a:cs typeface="Calibri" pitchFamily="34" charset="0"/>
+              </a:rPr>
+              <a:t>Kab</a:t>
+            </a:r>
+            <a:r>
+              <a:rPr lang="en-US" sz="1600" b="1" kern="0" dirty="0">
+                <a:solidFill>
+                  <a:srgbClr val="000000"/>
+                </a:solidFill>
+                <a:cs typeface="Calibri" pitchFamily="34" charset="0"/>
+              </a:rPr>
+              <a:t>.</a:t>
+            </a:r>
+            <a:r>
+              <a:rPr kumimoji="0" lang="en-US" sz="1600" b="1" i="0" u="none" strike="noStrike" kern="0" cap="none" spc="0" normalizeH="0" baseline="0" noProof="0" dirty="0">
                 <a:ln>
                   <a:noFill/>
                 </a:ln>
@@ -4818,12 +4956,56 @@
                 <a:effectLst/>
                 <a:uLnTx/>
                 <a:uFillTx/>
-                <a:latin typeface="+mn-lt"/>
+                <a:cs typeface="Calibri" pitchFamily="34" charset="0"/>
+              </a:rPr>
+              <a:t> </a:t>
+            </a:r>
+            <a:r>
+              <a:rPr kumimoji="0" lang="en-US" sz="1600" b="1" i="0" u="none" strike="noStrike" kern="0" cap="none" spc="0" normalizeH="0" baseline="0" noProof="0" dirty="0" err="1" smtClean="0">
+                <a:ln>
+                  <a:noFill/>
+                </a:ln>
+                <a:solidFill>
+                  <a:srgbClr val="000000"/>
+                </a:solidFill>
+                <a:effectLst/>
+                <a:uLnTx/>
+                <a:uFillTx/>
                 <a:cs typeface="Calibri" pitchFamily="34" charset="0"/>
               </a:rPr>
               <a:t>Berau</a:t>
             </a:r>
-            <a:endParaRPr kumimoji="0" lang="en-US" sz="1600" i="0" u="none" strike="noStrike" kern="0" cap="none" spc="0" normalizeH="0" baseline="0" noProof="0" dirty="0">
+            <a:r>
+              <a:rPr kumimoji="0" lang="en-US" sz="1600" b="1" i="0" u="none" strike="noStrike" kern="0" cap="none" spc="0" normalizeH="0" baseline="0" noProof="0" dirty="0" smtClean="0">
+                <a:ln>
+                  <a:noFill/>
+                </a:ln>
+                <a:solidFill>
+                  <a:srgbClr val="000000"/>
+                </a:solidFill>
+                <a:effectLst/>
+                <a:uLnTx/>
+                <a:uFillTx/>
+                <a:cs typeface="Calibri" pitchFamily="34" charset="0"/>
+              </a:rPr>
+              <a:t>, Prop. Kalimantan </a:t>
+            </a:r>
+            <a:r>
+              <a:rPr kumimoji="0" lang="en-US" sz="1600" b="1" i="0" u="none" strike="noStrike" kern="0" cap="none" spc="0" normalizeH="0" baseline="0" noProof="0" dirty="0" err="1" smtClean="0">
+                <a:ln>
+                  <a:noFill/>
+                </a:ln>
+                <a:solidFill>
+                  <a:srgbClr val="000000"/>
+                </a:solidFill>
+                <a:effectLst/>
+                <a:uLnTx/>
+                <a:uFillTx/>
+                <a:cs typeface="Calibri" pitchFamily="34" charset="0"/>
+              </a:rPr>
+              <a:t>Timur</a:t>
+            </a:r>
+            <a:endParaRPr kumimoji="0" lang="en-US" sz="1600" b="1" i="0" u="none" strike="noStrike" kern="0" cap="none" spc="0" normalizeH="0" baseline="0" noProof="0" dirty="0">
               <a:ln>
                 <a:noFill/>
               </a:ln>
@@ -4833,7 +5015,6 @@
               <a:effectLst/>
               <a:uLnTx/>
               <a:uFillTx/>
-              <a:latin typeface="+mn-lt"/>
               <a:cs typeface="Calibri" pitchFamily="34" charset="0"/>
             </a:endParaRPr>
           </a:p>
@@ -4885,8 +5066,61 @@
                 <a:latin typeface="+mn-lt"/>
                 <a:cs typeface="Calibri" pitchFamily="34" charset="0"/>
               </a:rPr>
-              <a:t>			:  XXX</a:t>
-            </a:r>
+              <a:t>			:  </a:t>
+            </a:r>
+            <a:r>
+              <a:rPr kumimoji="0" lang="en-US" sz="1600" b="1" i="0" u="none" strike="noStrike" kern="0" cap="none" spc="0" normalizeH="0" baseline="0" noProof="0" dirty="0" err="1" smtClean="0">
+                <a:ln>
+                  <a:noFill/>
+                </a:ln>
+                <a:solidFill>
+                  <a:srgbClr val="000000"/>
+                </a:solidFill>
+                <a:effectLst/>
+                <a:uLnTx/>
+                <a:uFillTx/>
+                <a:latin typeface="+mn-lt"/>
+                <a:cs typeface="Calibri" pitchFamily="34" charset="0"/>
+              </a:rPr>
+              <a:t>Tahun</a:t>
+            </a:r>
+            <a:r>
+              <a:rPr kumimoji="0" lang="en-US" sz="1600" i="0" u="none" strike="noStrike" kern="0" cap="none" spc="0" normalizeH="0" baseline="0" noProof="0" dirty="0" smtClean="0">
+                <a:ln>
+                  <a:noFill/>
+                </a:ln>
+                <a:solidFill>
+                  <a:srgbClr val="000000"/>
+                </a:solidFill>
+                <a:effectLst/>
+                <a:uLnTx/>
+                <a:uFillTx/>
+                <a:latin typeface="+mn-lt"/>
+                <a:cs typeface="Calibri" pitchFamily="34" charset="0"/>
+              </a:rPr>
+              <a:t> </a:t>
+            </a:r>
+            <a:r>
+              <a:rPr lang="en-US" sz="1600" b="1" kern="0" dirty="0" smtClean="0">
+                <a:solidFill>
+                  <a:srgbClr val="000000"/>
+                </a:solidFill>
+                <a:cs typeface="Calibri" pitchFamily="34" charset="0"/>
+              </a:rPr>
+              <a:t>2020</a:t>
+            </a:r>
+            <a:endParaRPr kumimoji="0" lang="en-US" sz="1600" b="1" i="0" u="none" strike="noStrike" kern="0" cap="none" spc="0" normalizeH="0" baseline="0" noProof="0" dirty="0">
+              <a:ln>
+                <a:noFill/>
+              </a:ln>
+              <a:solidFill>
+                <a:srgbClr val="000000"/>
+              </a:solidFill>
+              <a:effectLst/>
+              <a:uLnTx/>
+              <a:uFillTx/>
+              <a:cs typeface="Calibri" pitchFamily="34" charset="0"/>
+            </a:endParaRPr>
           </a:p>
           <a:p>
             <a:pPr marL="0" marR="0" lvl="0" indent="0" defTabSz="914400" eaLnBrk="1" fontAlgn="auto" latinLnBrk="0" hangingPunct="1">
@@ -4936,7 +5170,52 @@
                 <a:latin typeface="+mn-lt"/>
                 <a:cs typeface="Calibri" pitchFamily="34" charset="0"/>
               </a:rPr>
-              <a:t>			: - CPO (Crude Palm Oil)</a:t>
+              <a:t>			: </a:t>
+            </a:r>
+            <a:r>
+              <a:rPr kumimoji="0" lang="en-US" sz="1600" b="1" i="0" u="none" strike="noStrike" kern="0" cap="none" spc="0" normalizeH="0" baseline="0" noProof="0" dirty="0">
+                <a:ln>
+                  <a:noFill/>
+                </a:ln>
+                <a:solidFill>
+                  <a:srgbClr val="000000"/>
+                </a:solidFill>
+                <a:effectLst/>
+                <a:uLnTx/>
+                <a:uFillTx/>
+                <a:cs typeface="Calibri" pitchFamily="34" charset="0"/>
+              </a:rPr>
+              <a:t>- CPO (</a:t>
+            </a:r>
+            <a:r>
+              <a:rPr kumimoji="0" lang="en-US" sz="1600" b="1" i="1" u="none" strike="noStrike" kern="0" cap="none" spc="0" normalizeH="0" baseline="0" noProof="0" dirty="0">
+                <a:ln>
+                  <a:noFill/>
+                </a:ln>
+                <a:solidFill>
+                  <a:srgbClr val="000000"/>
+                </a:solidFill>
+                <a:effectLst/>
+                <a:uLnTx/>
+                <a:uFillTx/>
+                <a:cs typeface="Calibri" pitchFamily="34" charset="0"/>
+              </a:rPr>
+              <a:t>Crude Palm Oil</a:t>
+            </a:r>
+            <a:r>
+              <a:rPr kumimoji="0" lang="en-US" sz="1600" b="1" i="0" u="none" strike="noStrike" kern="0" cap="none" spc="0" normalizeH="0" baseline="0" noProof="0" dirty="0">
+                <a:ln>
+                  <a:noFill/>
+                </a:ln>
+                <a:solidFill>
+                  <a:srgbClr val="000000"/>
+                </a:solidFill>
+                <a:effectLst/>
+                <a:uLnTx/>
+                <a:uFillTx/>
+                <a:cs typeface="Calibri" pitchFamily="34" charset="0"/>
+              </a:rPr>
+              <a:t>)</a:t>
             </a:r>
           </a:p>
           <a:p>
@@ -4958,7 +5237,7 @@
               <a:defRPr/>
             </a:pPr>
             <a:r>
-              <a:rPr kumimoji="0" lang="en-US" sz="1600" i="0" u="none" strike="noStrike" kern="0" cap="none" spc="0" normalizeH="0" baseline="0" noProof="0" dirty="0">
+              <a:rPr kumimoji="0" lang="en-US" sz="1600" b="1" i="0" u="none" strike="noStrike" kern="0" cap="none" spc="0" normalizeH="0" baseline="0" noProof="0" dirty="0">
                 <a:ln>
                   <a:noFill/>
                 </a:ln>
@@ -4968,10 +5247,39 @@
                 <a:effectLst/>
                 <a:uLnTx/>
                 <a:uFillTx/>
-                <a:latin typeface="+mn-lt"/>
                 <a:cs typeface="Calibri" pitchFamily="34" charset="0"/>
               </a:rPr>
-              <a:t>		  	  - PK     (Palm Kernel)</a:t>
+              <a:t>		  	  - PK     (</a:t>
+            </a:r>
+            <a:r>
+              <a:rPr kumimoji="0" lang="en-US" sz="1600" b="1" i="1" u="none" strike="noStrike" kern="0" cap="none" spc="0" normalizeH="0" baseline="0" noProof="0" dirty="0">
+                <a:ln>
+                  <a:noFill/>
+                </a:ln>
+                <a:solidFill>
+                  <a:srgbClr val="000000"/>
+                </a:solidFill>
+                <a:effectLst/>
+                <a:uLnTx/>
+                <a:uFillTx/>
+                <a:cs typeface="Calibri" pitchFamily="34" charset="0"/>
+              </a:rPr>
+              <a:t>Palm Kernel</a:t>
+            </a:r>
+            <a:r>
+              <a:rPr kumimoji="0" lang="en-US" sz="1600" b="1" i="0" u="none" strike="noStrike" kern="0" cap="none" spc="0" normalizeH="0" baseline="0" noProof="0" dirty="0" smtClean="0">
+                <a:ln>
+                  <a:noFill/>
+                </a:ln>
+                <a:solidFill>
+                  <a:srgbClr val="000000"/>
+                </a:solidFill>
+                <a:effectLst/>
+                <a:uLnTx/>
+                <a:uFillTx/>
+                <a:cs typeface="Calibri" pitchFamily="34" charset="0"/>
+              </a:rPr>
+              <a:t>)</a:t>
             </a:r>
           </a:p>
           <a:p>
@@ -4993,21 +5301,71 @@
               <a:defRPr/>
             </a:pPr>
             <a:r>
-              <a:rPr kumimoji="0" lang="en-US" sz="1600" i="0" u="none" strike="noStrike" kern="0" cap="none" spc="0" normalizeH="0" baseline="0" noProof="0" dirty="0">
-                <a:ln>
-                  <a:noFill/>
-                </a:ln>
+              <a:rPr lang="en-US" sz="1600" b="1" kern="0" dirty="0">
                 <a:solidFill>
                   <a:srgbClr val="000000"/>
                 </a:solidFill>
-                <a:effectLst/>
-                <a:uLnTx/>
-                <a:uFillTx/>
-                <a:latin typeface="+mn-lt"/>
                 <a:cs typeface="Calibri" pitchFamily="34" charset="0"/>
               </a:rPr>
-              <a:t>Luas			: xxx Ha</a:t>
-            </a:r>
+              <a:t>	</a:t>
+            </a:r>
+            <a:r>
+              <a:rPr lang="en-US" sz="1600" b="1" kern="0" dirty="0" smtClean="0">
+                <a:solidFill>
+                  <a:srgbClr val="000000"/>
+                </a:solidFill>
+                <a:cs typeface="Calibri" pitchFamily="34" charset="0"/>
+              </a:rPr>
+              <a:t>		  - </a:t>
+            </a:r>
+            <a:r>
+              <a:rPr lang="en-US" sz="1600" b="1" kern="0" dirty="0" err="1" smtClean="0">
+                <a:solidFill>
+                  <a:srgbClr val="000000"/>
+                </a:solidFill>
+                <a:cs typeface="Calibri" pitchFamily="34" charset="0"/>
+              </a:rPr>
+              <a:t>Cangkang</a:t>
+            </a:r>
+            <a:r>
+              <a:rPr lang="en-US" sz="1600" b="1" kern="0" dirty="0" smtClean="0">
+                <a:solidFill>
+                  <a:srgbClr val="000000"/>
+                </a:solidFill>
+                <a:cs typeface="Calibri" pitchFamily="34" charset="0"/>
+              </a:rPr>
+              <a:t> (</a:t>
+            </a:r>
+            <a:r>
+              <a:rPr lang="en-US" sz="1600" b="1" i="1" kern="0" dirty="0" smtClean="0">
+                <a:solidFill>
+                  <a:srgbClr val="000000"/>
+                </a:solidFill>
+                <a:cs typeface="Calibri" pitchFamily="34" charset="0"/>
+              </a:rPr>
+              <a:t>Palm Oil Shell</a:t>
+            </a:r>
+            <a:r>
+              <a:rPr lang="en-US" sz="1600" b="1" kern="0" dirty="0" smtClean="0">
+                <a:solidFill>
+                  <a:srgbClr val="000000"/>
+                </a:solidFill>
+                <a:cs typeface="Calibri" pitchFamily="34" charset="0"/>
+              </a:rPr>
+              <a:t>)</a:t>
+            </a:r>
+            <a:endParaRPr kumimoji="0" lang="en-US" sz="1600" b="1" i="0" u="none" strike="noStrike" kern="0" cap="none" spc="0" normalizeH="0" baseline="0" noProof="0" dirty="0">
+              <a:ln>
+                <a:noFill/>
+              </a:ln>
+              <a:solidFill>
+                <a:srgbClr val="000000"/>
+              </a:solidFill>
+              <a:effectLst/>
+              <a:uLnTx/>
+              <a:uFillTx/>
+              <a:cs typeface="Calibri" pitchFamily="34" charset="0"/>
+            </a:endParaRPr>
           </a:p>
           <a:p>
             <a:pPr marL="0" marR="0" lvl="0" indent="0" defTabSz="914400" eaLnBrk="1" fontAlgn="auto" latinLnBrk="0" hangingPunct="1">
@@ -5028,20 +5386,49 @@
               <a:defRPr/>
             </a:pPr>
             <a:r>
-              <a:rPr kumimoji="0" lang="en-US" sz="1600" i="0" u="none" strike="noStrike" kern="0" cap="none" spc="0" normalizeH="0" baseline="0" noProof="0" dirty="0" err="1">
-                <a:ln>
-                  <a:noFill/>
-                </a:ln>
+              <a:rPr lang="en-US" sz="1600" kern="0" dirty="0" err="1" smtClean="0">
                 <a:solidFill>
                   <a:srgbClr val="000000"/>
                 </a:solidFill>
-                <a:effectLst/>
-                <a:uLnTx/>
-                <a:uFillTx/>
-                <a:latin typeface="+mn-lt"/>
                 <a:cs typeface="Calibri" pitchFamily="34" charset="0"/>
               </a:rPr>
               <a:t>Jumlah</a:t>
+            </a:r>
+            <a:r>
+              <a:rPr lang="en-US" sz="1600" kern="0" dirty="0" smtClean="0">
+                <a:solidFill>
+                  <a:srgbClr val="000000"/>
+                </a:solidFill>
+                <a:cs typeface="Calibri" pitchFamily="34" charset="0"/>
+              </a:rPr>
+              <a:t> </a:t>
+            </a:r>
+            <a:r>
+              <a:rPr lang="en-US" sz="1600" kern="0" dirty="0" err="1" smtClean="0">
+                <a:solidFill>
+                  <a:srgbClr val="000000"/>
+                </a:solidFill>
+                <a:cs typeface="Calibri" pitchFamily="34" charset="0"/>
+              </a:rPr>
+              <a:t>Tenaga</a:t>
+            </a:r>
+            <a:r>
+              <a:rPr lang="en-US" sz="1600" kern="0" dirty="0" smtClean="0">
+                <a:solidFill>
+                  <a:srgbClr val="000000"/>
+                </a:solidFill>
+                <a:cs typeface="Calibri" pitchFamily="34" charset="0"/>
+              </a:rPr>
+              <a:t> </a:t>
+            </a:r>
+            <a:r>
+              <a:rPr lang="en-US" sz="1600" kern="0" dirty="0" err="1" smtClean="0">
+                <a:solidFill>
+                  <a:srgbClr val="000000"/>
+                </a:solidFill>
+                <a:cs typeface="Calibri" pitchFamily="34" charset="0"/>
+              </a:rPr>
+              <a:t>Kerja</a:t>
             </a:r>
             <a:r>
               <a:rPr kumimoji="0" lang="en-US" sz="1600" i="0" u="none" strike="noStrike" kern="0" cap="none" spc="0" normalizeH="0" baseline="0" noProof="0" dirty="0">
@@ -5057,40 +5444,48 @@
                 <a:latin typeface="+mn-lt"/>
                 <a:cs typeface="Calibri" pitchFamily="34" charset="0"/>
               </a:rPr>
-              <a:t> </a:t>
-            </a:r>
-            <a:r>
-              <a:rPr kumimoji="0" lang="en-US" sz="1600" i="0" u="none" strike="noStrike" kern="0" cap="none" spc="0" normalizeH="0" baseline="0" noProof="0" dirty="0" err="1">
-                <a:ln>
-                  <a:noFill/>
-                </a:ln>
+              <a:t>		: </a:t>
+            </a:r>
+            <a:r>
+              <a:rPr lang="en-US" sz="1600" b="1" kern="0" dirty="0" smtClean="0">
                 <a:solidFill>
                   <a:srgbClr val="000000"/>
                 </a:solidFill>
-                <a:effectLst/>
-                <a:uLnTx/>
-                <a:uFillTx/>
-                <a:latin typeface="+mn-lt"/>
                 <a:cs typeface="Calibri" pitchFamily="34" charset="0"/>
               </a:rPr>
-              <a:t>Karyawan</a:t>
-            </a:r>
-            <a:r>
-              <a:rPr kumimoji="0" lang="en-US" sz="1600" i="0" u="none" strike="noStrike" kern="0" cap="none" spc="0" normalizeH="0" baseline="0" noProof="0" dirty="0">
-                <a:ln>
-                  <a:noFill/>
-                </a:ln>
-                <a:solidFill>
-                  <a:srgbClr val="000000"/>
-                </a:solidFill>
-                <a:effectLst/>
-                <a:uLnTx/>
-                <a:uFillTx/>
-                <a:latin typeface="+mn-lt"/>
-                <a:cs typeface="Calibri" pitchFamily="34" charset="0"/>
-              </a:rPr>
-              <a:t>		: xxx orang</a:t>
-            </a:r>
+              <a:t>89 Orang</a:t>
+            </a:r>
+            <a:endParaRPr kumimoji="0" lang="en-US" sz="1600" b="1" i="0" u="none" strike="noStrike" kern="0" cap="none" spc="0" normalizeH="0" baseline="0" noProof="0" dirty="0">
+              <a:ln>
+                <a:noFill/>
+              </a:ln>
+              <a:solidFill>
+                <a:srgbClr val="000000"/>
+              </a:solidFill>
+              <a:effectLst/>
+              <a:uLnTx/>
+              <a:uFillTx/>
+              <a:cs typeface="Calibri" pitchFamily="34" charset="0"/>
+            </a:endParaRPr>
+          </a:p>
+          <a:p>
+            <a:pPr marL="0" marR="0" lvl="0" indent="0" defTabSz="914400" eaLnBrk="1" fontAlgn="auto" latinLnBrk="0" hangingPunct="1">
+              <a:lnSpc>
+                <a:spcPct val="100000"/>
+              </a:lnSpc>
+              <a:spcBef>
+                <a:spcPts val="0"/>
+              </a:spcBef>
+              <a:spcAft>
+                <a:spcPts val="0"/>
+              </a:spcAft>
+              <a:buClrTx/>
+              <a:buSzTx/>
+              <a:buFontTx/>
+              <a:buNone/>
+              <a:tabLst/>
+              <a:defRPr/>
+            </a:pPr>
             <a:endParaRPr kumimoji="0" lang="id-ID" sz="1600" i="0" u="none" strike="noStrike" kern="0" cap="none" spc="0" normalizeH="0" baseline="0" noProof="0" dirty="0">
               <a:ln>
                 <a:noFill/>
@@ -5112,7 +5507,7 @@
           <p:cNvPr id="6" name="TextBox 5">
             <a:extLst>
               <a:ext uri="{FF2B5EF4-FFF2-40B4-BE49-F238E27FC236}">
-                <a16:creationId xmlns:a16="http://schemas.microsoft.com/office/drawing/2014/main" id="{3A1C7B42-914F-A3F1-2AD7-C5EEA3282C4A}"/>
+                <a16:creationId xmlns:a16="http://schemas.microsoft.com/office/drawing/2014/main" xmlns="" id="{3A1C7B42-914F-A3F1-2AD7-C5EEA3282C4A}"/>
               </a:ext>
             </a:extLst>
           </p:cNvPr>
@@ -5121,7 +5516,7 @@
         </p:nvSpPr>
         <p:spPr>
           <a:xfrm>
-            <a:off x="234903" y="3275112"/>
+            <a:off x="223233" y="3401743"/>
             <a:ext cx="11845480" cy="307775"/>
           </a:xfrm>
           <a:prstGeom prst="rect">
@@ -5161,7 +5556,7 @@
           <p:cNvPr id="5" name="Picture 4">
             <a:extLst>
               <a:ext uri="{FF2B5EF4-FFF2-40B4-BE49-F238E27FC236}">
-                <a16:creationId xmlns:a16="http://schemas.microsoft.com/office/drawing/2014/main" id="{B4C4F558-4AE0-2A65-0CD7-73D1C24B15B6}"/>
+                <a16:creationId xmlns:a16="http://schemas.microsoft.com/office/drawing/2014/main" xmlns="" id="{B4C4F558-4AE0-2A65-0CD7-73D1C24B15B6}"/>
               </a:ext>
             </a:extLst>
           </p:cNvPr>
@@ -5179,7 +5574,7 @@
         </p:blipFill>
         <p:spPr>
           <a:xfrm>
-            <a:off x="223233" y="3697677"/>
+            <a:off x="223232" y="3793909"/>
             <a:ext cx="11845481" cy="2964699"/>
           </a:xfrm>
           <a:prstGeom prst="rect">
@@ -5208,7 +5603,7 @@
         <p:cNvPr id="1" name="">
           <a:extLst>
             <a:ext uri="{FF2B5EF4-FFF2-40B4-BE49-F238E27FC236}">
-              <a16:creationId xmlns:a16="http://schemas.microsoft.com/office/drawing/2014/main" id="{215A67C8-C1F7-6853-EA42-9D0F642419D2}"/>
+              <a16:creationId xmlns:a16="http://schemas.microsoft.com/office/drawing/2014/main" xmlns="" id="{215A67C8-C1F7-6853-EA42-9D0F642419D2}"/>
             </a:ext>
           </a:extLst>
         </p:cNvPr>
@@ -5228,7 +5623,7 @@
           <p:cNvPr id="2" name="Title 1">
             <a:extLst>
               <a:ext uri="{FF2B5EF4-FFF2-40B4-BE49-F238E27FC236}">
-                <a16:creationId xmlns:a16="http://schemas.microsoft.com/office/drawing/2014/main" id="{A2FEE164-B5DF-8911-2A70-2883BC76E143}"/>
+                <a16:creationId xmlns:a16="http://schemas.microsoft.com/office/drawing/2014/main" xmlns="" id="{A2FEE164-B5DF-8911-2A70-2883BC76E143}"/>
               </a:ext>
             </a:extLst>
           </p:cNvPr>
@@ -5283,7 +5678,7 @@
           <p:cNvPr id="4" name="Straight Connector 3">
             <a:extLst>
               <a:ext uri="{FF2B5EF4-FFF2-40B4-BE49-F238E27FC236}">
-                <a16:creationId xmlns:a16="http://schemas.microsoft.com/office/drawing/2014/main" id="{AD9195B1-C7A3-DA93-41BA-A6A4A2737664}"/>
+                <a16:creationId xmlns:a16="http://schemas.microsoft.com/office/drawing/2014/main" xmlns="" id="{AD9195B1-C7A3-DA93-41BA-A6A4A2737664}"/>
               </a:ext>
             </a:extLst>
           </p:cNvPr>
@@ -5326,7 +5721,7 @@
           <p:cNvPr id="8" name="Straight Connector 7">
             <a:extLst>
               <a:ext uri="{FF2B5EF4-FFF2-40B4-BE49-F238E27FC236}">
-                <a16:creationId xmlns:a16="http://schemas.microsoft.com/office/drawing/2014/main" id="{332ABD43-BD85-BEFA-90AB-0471A4FB1A44}"/>
+                <a16:creationId xmlns:a16="http://schemas.microsoft.com/office/drawing/2014/main" xmlns="" id="{332ABD43-BD85-BEFA-90AB-0471A4FB1A44}"/>
               </a:ext>
             </a:extLst>
           </p:cNvPr>
@@ -5369,7 +5764,7 @@
           <p:cNvPr id="10" name="Table 9">
             <a:extLst>
               <a:ext uri="{FF2B5EF4-FFF2-40B4-BE49-F238E27FC236}">
-                <a16:creationId xmlns:a16="http://schemas.microsoft.com/office/drawing/2014/main" id="{EC7B766D-36E4-DE44-DF40-CCD0312F4EB3}"/>
+                <a16:creationId xmlns:a16="http://schemas.microsoft.com/office/drawing/2014/main" xmlns="" id="{EC7B766D-36E4-DE44-DF40-CCD0312F4EB3}"/>
               </a:ext>
             </a:extLst>
           </p:cNvPr>
@@ -5379,7 +5774,7 @@
           <p:nvPr>
             <p:extLst>
               <p:ext uri="{D42A27DB-BD31-4B8C-83A1-F6EECF244321}">
-                <p14:modId xmlns:p14="http://schemas.microsoft.com/office/powerpoint/2010/main" val="327067258"/>
+                <p14:modId xmlns:p14="http://schemas.microsoft.com/office/powerpoint/2010/main" val="1814548903"/>
               </p:ext>
             </p:extLst>
           </p:nvPr>
@@ -5398,35 +5793,35 @@
                 <a:gridCol w="1003094">
                   <a:extLst>
                     <a:ext uri="{9D8B030D-6E8A-4147-A177-3AD203B41FA5}">
-                      <a16:colId xmlns:a16="http://schemas.microsoft.com/office/drawing/2014/main" val="1912165937"/>
+                      <a16:colId xmlns:a16="http://schemas.microsoft.com/office/drawing/2014/main" xmlns="" val="1912165937"/>
                     </a:ext>
                   </a:extLst>
                 </a:gridCol>
                 <a:gridCol w="208280">
                   <a:extLst>
                     <a:ext uri="{9D8B030D-6E8A-4147-A177-3AD203B41FA5}">
-                      <a16:colId xmlns:a16="http://schemas.microsoft.com/office/drawing/2014/main" val="739493235"/>
+                      <a16:colId xmlns:a16="http://schemas.microsoft.com/office/drawing/2014/main" xmlns="" val="739493235"/>
                     </a:ext>
                   </a:extLst>
                 </a:gridCol>
                 <a:gridCol w="627006">
                   <a:extLst>
                     <a:ext uri="{9D8B030D-6E8A-4147-A177-3AD203B41FA5}">
-                      <a16:colId xmlns:a16="http://schemas.microsoft.com/office/drawing/2014/main" val="356708746"/>
+                      <a16:colId xmlns:a16="http://schemas.microsoft.com/office/drawing/2014/main" xmlns="" val="356708746"/>
                     </a:ext>
                   </a:extLst>
                 </a:gridCol>
                 <a:gridCol w="467666">
                   <a:extLst>
                     <a:ext uri="{9D8B030D-6E8A-4147-A177-3AD203B41FA5}">
-                      <a16:colId xmlns:a16="http://schemas.microsoft.com/office/drawing/2014/main" val="2762673741"/>
+                      <a16:colId xmlns:a16="http://schemas.microsoft.com/office/drawing/2014/main" xmlns="" val="2762673741"/>
                     </a:ext>
                   </a:extLst>
                 </a:gridCol>
                 <a:gridCol w="4478033">
                   <a:extLst>
                     <a:ext uri="{9D8B030D-6E8A-4147-A177-3AD203B41FA5}">
-                      <a16:colId xmlns:a16="http://schemas.microsoft.com/office/drawing/2014/main" val="1249775533"/>
+                      <a16:colId xmlns:a16="http://schemas.microsoft.com/office/drawing/2014/main" xmlns="" val="1249775533"/>
                     </a:ext>
                   </a:extLst>
                 </a:gridCol>
@@ -5438,8 +5833,8 @@
                     <a:lstStyle/>
                     <a:p>
                       <a:r>
-                        <a:rPr lang="en-US" sz="2400" dirty="0" err="1"/>
-                        <a:t>LaSak</a:t>
+                        <a:rPr lang="en-US" sz="2400" dirty="0" err="1" smtClean="0"/>
+                        <a:t>LaSaK</a:t>
                       </a:r>
                       <a:endParaRPr lang="en-US" sz="2400" dirty="0"/>
                     </a:p>
@@ -5632,7 +6027,7 @@
                 </a:tc>
                 <a:extLst>
                   <a:ext uri="{0D108BD9-81ED-4DB2-BD59-A6C34878D82A}">
-                    <a16:rowId xmlns:a16="http://schemas.microsoft.com/office/drawing/2014/main" val="1574752478"/>
+                    <a16:rowId xmlns:a16="http://schemas.microsoft.com/office/drawing/2014/main" xmlns="" val="1574752478"/>
                   </a:ext>
                 </a:extLst>
               </a:tr>
@@ -5876,7 +6271,7 @@
                 </a:tc>
                 <a:extLst>
                   <a:ext uri="{0D108BD9-81ED-4DB2-BD59-A6C34878D82A}">
-                    <a16:rowId xmlns:a16="http://schemas.microsoft.com/office/drawing/2014/main" val="4013036535"/>
+                    <a16:rowId xmlns:a16="http://schemas.microsoft.com/office/drawing/2014/main" xmlns="" val="4013036535"/>
                   </a:ext>
                 </a:extLst>
               </a:tr>
@@ -6120,7 +6515,7 @@
                 </a:tc>
                 <a:extLst>
                   <a:ext uri="{0D108BD9-81ED-4DB2-BD59-A6C34878D82A}">
-                    <a16:rowId xmlns:a16="http://schemas.microsoft.com/office/drawing/2014/main" val="4263892998"/>
+                    <a16:rowId xmlns:a16="http://schemas.microsoft.com/office/drawing/2014/main" xmlns="" val="4263892998"/>
                   </a:ext>
                 </a:extLst>
               </a:tr>
@@ -6373,7 +6768,7 @@
                 </a:tc>
                 <a:extLst>
                   <a:ext uri="{0D108BD9-81ED-4DB2-BD59-A6C34878D82A}">
-                    <a16:rowId xmlns:a16="http://schemas.microsoft.com/office/drawing/2014/main" val="2985509580"/>
+                    <a16:rowId xmlns:a16="http://schemas.microsoft.com/office/drawing/2014/main" xmlns="" val="2985509580"/>
                   </a:ext>
                 </a:extLst>
               </a:tr>
@@ -6810,7 +7205,7 @@
                 </a:tc>
                 <a:extLst>
                   <a:ext uri="{0D108BD9-81ED-4DB2-BD59-A6C34878D82A}">
-                    <a16:rowId xmlns:a16="http://schemas.microsoft.com/office/drawing/2014/main" val="3424715728"/>
+                    <a16:rowId xmlns:a16="http://schemas.microsoft.com/office/drawing/2014/main" xmlns="" val="3424715728"/>
                   </a:ext>
                 </a:extLst>
               </a:tr>
@@ -7288,7 +7683,7 @@
                 </a:tc>
                 <a:extLst>
                   <a:ext uri="{0D108BD9-81ED-4DB2-BD59-A6C34878D82A}">
-                    <a16:rowId xmlns:a16="http://schemas.microsoft.com/office/drawing/2014/main" val="3808879371"/>
+                    <a16:rowId xmlns:a16="http://schemas.microsoft.com/office/drawing/2014/main" xmlns="" val="3808879371"/>
                   </a:ext>
                 </a:extLst>
               </a:tr>
@@ -7716,7 +8111,7 @@
                 </a:tc>
                 <a:extLst>
                   <a:ext uri="{0D108BD9-81ED-4DB2-BD59-A6C34878D82A}">
-                    <a16:rowId xmlns:a16="http://schemas.microsoft.com/office/drawing/2014/main" val="3853326527"/>
+                    <a16:rowId xmlns:a16="http://schemas.microsoft.com/office/drawing/2014/main" xmlns="" val="3853326527"/>
                   </a:ext>
                 </a:extLst>
               </a:tr>
@@ -8028,7 +8423,7 @@
                 </a:tc>
                 <a:extLst>
                   <a:ext uri="{0D108BD9-81ED-4DB2-BD59-A6C34878D82A}">
-                    <a16:rowId xmlns:a16="http://schemas.microsoft.com/office/drawing/2014/main" val="4148185656"/>
+                    <a16:rowId xmlns:a16="http://schemas.microsoft.com/office/drawing/2014/main" xmlns="" val="4148185656"/>
                   </a:ext>
                 </a:extLst>
               </a:tr>
@@ -8293,7 +8688,7 @@
                 </a:tc>
                 <a:extLst>
                   <a:ext uri="{0D108BD9-81ED-4DB2-BD59-A6C34878D82A}">
-                    <a16:rowId xmlns:a16="http://schemas.microsoft.com/office/drawing/2014/main" val="3158030413"/>
+                    <a16:rowId xmlns:a16="http://schemas.microsoft.com/office/drawing/2014/main" xmlns="" val="3158030413"/>
                   </a:ext>
                 </a:extLst>
               </a:tr>
@@ -8306,7 +8701,7 @@
           <p:cNvPr id="12" name="Table 11">
             <a:extLst>
               <a:ext uri="{FF2B5EF4-FFF2-40B4-BE49-F238E27FC236}">
-                <a16:creationId xmlns:a16="http://schemas.microsoft.com/office/drawing/2014/main" id="{0C1657FB-077E-9722-192F-AE560342B096}"/>
+                <a16:creationId xmlns:a16="http://schemas.microsoft.com/office/drawing/2014/main" xmlns="" id="{0C1657FB-077E-9722-192F-AE560342B096}"/>
               </a:ext>
             </a:extLst>
           </p:cNvPr>
@@ -8335,14 +8730,14 @@
                 <a:gridCol w="800890">
                   <a:extLst>
                     <a:ext uri="{9D8B030D-6E8A-4147-A177-3AD203B41FA5}">
-                      <a16:colId xmlns:a16="http://schemas.microsoft.com/office/drawing/2014/main" val="307707419"/>
+                      <a16:colId xmlns:a16="http://schemas.microsoft.com/office/drawing/2014/main" xmlns="" val="307707419"/>
                     </a:ext>
                   </a:extLst>
                 </a:gridCol>
                 <a:gridCol w="1393672">
                   <a:extLst>
                     <a:ext uri="{9D8B030D-6E8A-4147-A177-3AD203B41FA5}">
-                      <a16:colId xmlns:a16="http://schemas.microsoft.com/office/drawing/2014/main" val="4065649630"/>
+                      <a16:colId xmlns:a16="http://schemas.microsoft.com/office/drawing/2014/main" xmlns="" val="4065649630"/>
                     </a:ext>
                   </a:extLst>
                 </a:gridCol>
@@ -8470,7 +8865,7 @@
                 </a:tc>
                 <a:extLst>
                   <a:ext uri="{0D108BD9-81ED-4DB2-BD59-A6C34878D82A}">
-                    <a16:rowId xmlns:a16="http://schemas.microsoft.com/office/drawing/2014/main" val="4198278792"/>
+                    <a16:rowId xmlns:a16="http://schemas.microsoft.com/office/drawing/2014/main" xmlns="" val="4198278792"/>
                   </a:ext>
                 </a:extLst>
               </a:tr>
@@ -8565,7 +8960,7 @@
                 </a:tc>
                 <a:extLst>
                   <a:ext uri="{0D108BD9-81ED-4DB2-BD59-A6C34878D82A}">
-                    <a16:rowId xmlns:a16="http://schemas.microsoft.com/office/drawing/2014/main" val="2184894139"/>
+                    <a16:rowId xmlns:a16="http://schemas.microsoft.com/office/drawing/2014/main" xmlns="" val="2184894139"/>
                   </a:ext>
                 </a:extLst>
               </a:tr>
@@ -8578,7 +8973,7 @@
           <p:cNvPr id="3" name="Table 2">
             <a:extLst>
               <a:ext uri="{FF2B5EF4-FFF2-40B4-BE49-F238E27FC236}">
-                <a16:creationId xmlns:a16="http://schemas.microsoft.com/office/drawing/2014/main" id="{85C7E924-210A-9612-DBEC-9870ADAB1672}"/>
+                <a16:creationId xmlns:a16="http://schemas.microsoft.com/office/drawing/2014/main" xmlns="" id="{85C7E924-210A-9612-DBEC-9870ADAB1672}"/>
               </a:ext>
             </a:extLst>
           </p:cNvPr>
@@ -8607,14 +9002,14 @@
                 <a:gridCol w="779886">
                   <a:extLst>
                     <a:ext uri="{9D8B030D-6E8A-4147-A177-3AD203B41FA5}">
-                      <a16:colId xmlns:a16="http://schemas.microsoft.com/office/drawing/2014/main" val="307707419"/>
+                      <a16:colId xmlns:a16="http://schemas.microsoft.com/office/drawing/2014/main" xmlns="" val="307707419"/>
                     </a:ext>
                   </a:extLst>
                 </a:gridCol>
                 <a:gridCol w="1414676">
                   <a:extLst>
                     <a:ext uri="{9D8B030D-6E8A-4147-A177-3AD203B41FA5}">
-                      <a16:colId xmlns:a16="http://schemas.microsoft.com/office/drawing/2014/main" val="4065649630"/>
+                      <a16:colId xmlns:a16="http://schemas.microsoft.com/office/drawing/2014/main" xmlns="" val="4065649630"/>
                     </a:ext>
                   </a:extLst>
                 </a:gridCol>
@@ -8742,7 +9137,7 @@
                 </a:tc>
                 <a:extLst>
                   <a:ext uri="{0D108BD9-81ED-4DB2-BD59-A6C34878D82A}">
-                    <a16:rowId xmlns:a16="http://schemas.microsoft.com/office/drawing/2014/main" val="4198278792"/>
+                    <a16:rowId xmlns:a16="http://schemas.microsoft.com/office/drawing/2014/main" xmlns="" val="4198278792"/>
                   </a:ext>
                 </a:extLst>
               </a:tr>
@@ -8834,7 +9229,7 @@
                 </a:tc>
                 <a:extLst>
                   <a:ext uri="{0D108BD9-81ED-4DB2-BD59-A6C34878D82A}">
-                    <a16:rowId xmlns:a16="http://schemas.microsoft.com/office/drawing/2014/main" val="2184894139"/>
+                    <a16:rowId xmlns:a16="http://schemas.microsoft.com/office/drawing/2014/main" xmlns="" val="2184894139"/>
                   </a:ext>
                 </a:extLst>
               </a:tr>
@@ -8847,7 +9242,7 @@
           <p:cNvPr id="5" name="Table 4">
             <a:extLst>
               <a:ext uri="{FF2B5EF4-FFF2-40B4-BE49-F238E27FC236}">
-                <a16:creationId xmlns:a16="http://schemas.microsoft.com/office/drawing/2014/main" id="{0EFDFF2E-ACA4-D8AC-FFD7-7C00D8407CA2}"/>
+                <a16:creationId xmlns:a16="http://schemas.microsoft.com/office/drawing/2014/main" xmlns="" id="{0EFDFF2E-ACA4-D8AC-FFD7-7C00D8407CA2}"/>
               </a:ext>
             </a:extLst>
           </p:cNvPr>
@@ -8876,14 +9271,14 @@
                 <a:gridCol w="779886">
                   <a:extLst>
                     <a:ext uri="{9D8B030D-6E8A-4147-A177-3AD203B41FA5}">
-                      <a16:colId xmlns:a16="http://schemas.microsoft.com/office/drawing/2014/main" val="307707419"/>
+                      <a16:colId xmlns:a16="http://schemas.microsoft.com/office/drawing/2014/main" xmlns="" val="307707419"/>
                     </a:ext>
                   </a:extLst>
                 </a:gridCol>
                 <a:gridCol w="1414676">
                   <a:extLst>
                     <a:ext uri="{9D8B030D-6E8A-4147-A177-3AD203B41FA5}">
-                      <a16:colId xmlns:a16="http://schemas.microsoft.com/office/drawing/2014/main" val="4065649630"/>
+                      <a16:colId xmlns:a16="http://schemas.microsoft.com/office/drawing/2014/main" xmlns="" val="4065649630"/>
                     </a:ext>
                   </a:extLst>
                 </a:gridCol>
@@ -9011,7 +9406,7 @@
                 </a:tc>
                 <a:extLst>
                   <a:ext uri="{0D108BD9-81ED-4DB2-BD59-A6C34878D82A}">
-                    <a16:rowId xmlns:a16="http://schemas.microsoft.com/office/drawing/2014/main" val="4198278792"/>
+                    <a16:rowId xmlns:a16="http://schemas.microsoft.com/office/drawing/2014/main" xmlns="" val="4198278792"/>
                   </a:ext>
                 </a:extLst>
               </a:tr>
@@ -9107,7 +9502,7 @@
                 </a:tc>
                 <a:extLst>
                   <a:ext uri="{0D108BD9-81ED-4DB2-BD59-A6C34878D82A}">
-                    <a16:rowId xmlns:a16="http://schemas.microsoft.com/office/drawing/2014/main" val="2184894139"/>
+                    <a16:rowId xmlns:a16="http://schemas.microsoft.com/office/drawing/2014/main" xmlns="" val="2184894139"/>
                   </a:ext>
                 </a:extLst>
               </a:tr>
@@ -9150,7 +9545,7 @@
           <p:cNvPr id="2" name="Title 1">
             <a:extLst>
               <a:ext uri="{FF2B5EF4-FFF2-40B4-BE49-F238E27FC236}">
-                <a16:creationId xmlns:a16="http://schemas.microsoft.com/office/drawing/2014/main" id="{9C02B344-64A3-EF8B-A749-67391BD4EE63}"/>
+                <a16:creationId xmlns:a16="http://schemas.microsoft.com/office/drawing/2014/main" xmlns="" id="{9C02B344-64A3-EF8B-A749-67391BD4EE63}"/>
               </a:ext>
             </a:extLst>
           </p:cNvPr>
@@ -9175,7 +9570,7 @@
           <p:cNvPr id="5" name="Table 4">
             <a:extLst>
               <a:ext uri="{FF2B5EF4-FFF2-40B4-BE49-F238E27FC236}">
-                <a16:creationId xmlns:a16="http://schemas.microsoft.com/office/drawing/2014/main" id="{D603F417-BDE9-2A51-D895-61FCD57B6DB4}"/>
+                <a16:creationId xmlns:a16="http://schemas.microsoft.com/office/drawing/2014/main" xmlns="" id="{D603F417-BDE9-2A51-D895-61FCD57B6DB4}"/>
               </a:ext>
             </a:extLst>
           </p:cNvPr>
@@ -9204,14 +9599,14 @@
                 <a:gridCol w="1295938">
                   <a:extLst>
                     <a:ext uri="{9D8B030D-6E8A-4147-A177-3AD203B41FA5}">
-                      <a16:colId xmlns:a16="http://schemas.microsoft.com/office/drawing/2014/main" val="232597012"/>
+                      <a16:colId xmlns:a16="http://schemas.microsoft.com/office/drawing/2014/main" xmlns="" val="232597012"/>
                     </a:ext>
                   </a:extLst>
                 </a:gridCol>
                 <a:gridCol w="7675809">
                   <a:extLst>
                     <a:ext uri="{9D8B030D-6E8A-4147-A177-3AD203B41FA5}">
-                      <a16:colId xmlns:a16="http://schemas.microsoft.com/office/drawing/2014/main" val="1685957260"/>
+                      <a16:colId xmlns:a16="http://schemas.microsoft.com/office/drawing/2014/main" xmlns="" val="1685957260"/>
                     </a:ext>
                   </a:extLst>
                 </a:gridCol>
@@ -9382,7 +9777,7 @@
                 </a:tc>
                 <a:extLst>
                   <a:ext uri="{0D108BD9-81ED-4DB2-BD59-A6C34878D82A}">
-                    <a16:rowId xmlns:a16="http://schemas.microsoft.com/office/drawing/2014/main" val="1973258458"/>
+                    <a16:rowId xmlns:a16="http://schemas.microsoft.com/office/drawing/2014/main" xmlns="" val="1973258458"/>
                   </a:ext>
                 </a:extLst>
               </a:tr>
@@ -9580,7 +9975,7 @@
                 </a:tc>
                 <a:extLst>
                   <a:ext uri="{0D108BD9-81ED-4DB2-BD59-A6C34878D82A}">
-                    <a16:rowId xmlns:a16="http://schemas.microsoft.com/office/drawing/2014/main" val="2161602426"/>
+                    <a16:rowId xmlns:a16="http://schemas.microsoft.com/office/drawing/2014/main" xmlns="" val="2161602426"/>
                   </a:ext>
                 </a:extLst>
               </a:tr>
@@ -9755,7 +10150,7 @@
                 </a:tc>
                 <a:extLst>
                   <a:ext uri="{0D108BD9-81ED-4DB2-BD59-A6C34878D82A}">
-                    <a16:rowId xmlns:a16="http://schemas.microsoft.com/office/drawing/2014/main" val="2649437814"/>
+                    <a16:rowId xmlns:a16="http://schemas.microsoft.com/office/drawing/2014/main" xmlns="" val="2649437814"/>
                   </a:ext>
                 </a:extLst>
               </a:tr>
@@ -9880,7 +10275,7 @@
                 </a:tc>
                 <a:extLst>
                   <a:ext uri="{0D108BD9-81ED-4DB2-BD59-A6C34878D82A}">
-                    <a16:rowId xmlns:a16="http://schemas.microsoft.com/office/drawing/2014/main" val="2488363310"/>
+                    <a16:rowId xmlns:a16="http://schemas.microsoft.com/office/drawing/2014/main" xmlns="" val="2488363310"/>
                   </a:ext>
                 </a:extLst>
               </a:tr>
@@ -9937,7 +10332,7 @@
           <p:cNvPr id="2" name="Title 1">
             <a:extLst>
               <a:ext uri="{FF2B5EF4-FFF2-40B4-BE49-F238E27FC236}">
-                <a16:creationId xmlns:a16="http://schemas.microsoft.com/office/drawing/2014/main" id="{E3B4839C-6D74-DFB6-4876-A0E37EF6A727}"/>
+                <a16:creationId xmlns:a16="http://schemas.microsoft.com/office/drawing/2014/main" xmlns="" id="{E3B4839C-6D74-DFB6-4876-A0E37EF6A727}"/>
               </a:ext>
             </a:extLst>
           </p:cNvPr>
@@ -9962,7 +10357,7 @@
           <p:cNvPr id="3" name="Content Placeholder 2">
             <a:extLst>
               <a:ext uri="{FF2B5EF4-FFF2-40B4-BE49-F238E27FC236}">
-                <a16:creationId xmlns:a16="http://schemas.microsoft.com/office/drawing/2014/main" id="{4752A19C-C00E-7869-4E89-0B0D3BED7B16}"/>
+                <a16:creationId xmlns:a16="http://schemas.microsoft.com/office/drawing/2014/main" xmlns="" id="{4752A19C-C00E-7869-4E89-0B0D3BED7B16}"/>
               </a:ext>
             </a:extLst>
           </p:cNvPr>
@@ -10038,7 +10433,7 @@
     </a:clrScheme>
     <a:fontScheme name="Calibri">
       <a:majorFont>
-        <a:latin typeface="Calibri" panose="020F0502020204030204"/>
+        <a:latin typeface="Calibri"/>
         <a:ea typeface=""/>
         <a:cs typeface=""/>
         <a:font script="Jpan" typeface="メイリオ"/>
@@ -10073,7 +10468,7 @@
         <a:font script="Geor" typeface="Sylfaen"/>
       </a:majorFont>
       <a:minorFont>
-        <a:latin typeface="Calibri" panose="020F0502020204030204"/>
+        <a:latin typeface="Calibri"/>
         <a:ea typeface=""/>
         <a:cs typeface=""/>
         <a:font script="Jpan" typeface="メイリオ"/>
@@ -10250,7 +10645,7 @@
   <a:extraClrSchemeLst/>
   <a:extLst>
     <a:ext uri="{05A4C25C-085E-4340-85A3-A5531E510DB2}">
-      <thm15:themeFamily xmlns:thm15="http://schemas.microsoft.com/office/thememl/2012/main" name="Office Theme" id="{62F939B6-93AF-4DB8-9C6B-D6C7DFDC589F}" vid="{4A3C46E8-61CC-4603-A589-7422A47A8E4A}"/>
+      <thm15:themeFamily xmlns:thm15="http://schemas.microsoft.com/office/thememl/2012/main" xmlns="" name="Office Theme" id="{62F939B6-93AF-4DB8-9C6B-D6C7DFDC589F}" vid="{4A3C46E8-61CC-4603-A589-7422A47A8E4A}"/>
     </a:ext>
   </a:extLst>
 </a:theme>
@@ -10299,7 +10694,7 @@
     </a:clrScheme>
     <a:fontScheme name="Office">
       <a:majorFont>
-        <a:latin typeface="Aptos Display" panose="02110004020202020204"/>
+        <a:latin typeface="Aptos Display"/>
         <a:ea typeface=""/>
         <a:cs typeface=""/>
         <a:font script="Jpan" typeface="游ゴシック Light"/>
@@ -10351,7 +10746,7 @@
         <a:font script="Tfng" typeface="Ebrima"/>
       </a:majorFont>
       <a:minorFont>
-        <a:latin typeface="Aptos" panose="02110004020202020204"/>
+        <a:latin typeface="Aptos"/>
         <a:ea typeface=""/>
         <a:cs typeface=""/>
         <a:font script="Jpan" typeface="游ゴシック"/>
@@ -10565,7 +10960,7 @@
   <a:extraClrSchemeLst/>
   <a:extLst>
     <a:ext uri="{05A4C25C-085E-4340-85A3-A5531E510DB2}">
-      <thm15:themeFamily xmlns:thm15="http://schemas.microsoft.com/office/thememl/2012/main" name="Office Theme" id="{2E142A2C-CD16-42D6-873A-C26D2A0506FA}" vid="{1BDDFF52-6CD6-40A5-AB3C-68EB2F1E4D0A}"/>
+      <thm15:themeFamily xmlns:thm15="http://schemas.microsoft.com/office/thememl/2012/main" xmlns="" name="Office Theme" id="{2E142A2C-CD16-42D6-873A-C26D2A0506FA}" vid="{1BDDFF52-6CD6-40A5-AB3C-68EB2F1E4D0A}"/>
     </a:ext>
   </a:extLst>
 </a:theme>

</xml_diff>